<commit_message>
added slide about pre vs post training in llm lecture, removed link to course eval in multilingual nlp lecture
</commit_message>
<xml_diff>
--- a/lectures/09_multilingual_nlp/09_multilingual_nlp.pptx
+++ b/lectures/09_multilingual_nlp/09_multilingual_nlp.pptx
@@ -15,34 +15,33 @@
     <p:sldId id="333" r:id="rId9"/>
     <p:sldId id="307" r:id="rId10"/>
     <p:sldId id="260" r:id="rId11"/>
-    <p:sldId id="332" r:id="rId12"/>
-    <p:sldId id="261" r:id="rId13"/>
-    <p:sldId id="308" r:id="rId14"/>
-    <p:sldId id="334" r:id="rId15"/>
-    <p:sldId id="328" r:id="rId16"/>
-    <p:sldId id="309" r:id="rId17"/>
-    <p:sldId id="310" r:id="rId18"/>
-    <p:sldId id="311" r:id="rId19"/>
-    <p:sldId id="312" r:id="rId20"/>
-    <p:sldId id="314" r:id="rId21"/>
-    <p:sldId id="317" r:id="rId22"/>
-    <p:sldId id="315" r:id="rId23"/>
-    <p:sldId id="300" r:id="rId24"/>
-    <p:sldId id="318" r:id="rId25"/>
-    <p:sldId id="319" r:id="rId26"/>
-    <p:sldId id="321" r:id="rId27"/>
-    <p:sldId id="320" r:id="rId28"/>
-    <p:sldId id="322" r:id="rId29"/>
-    <p:sldId id="323" r:id="rId30"/>
-    <p:sldId id="324" r:id="rId31"/>
-    <p:sldId id="329" r:id="rId32"/>
-    <p:sldId id="330" r:id="rId33"/>
-    <p:sldId id="331" r:id="rId34"/>
-    <p:sldId id="325" r:id="rId35"/>
-    <p:sldId id="326" r:id="rId36"/>
-    <p:sldId id="335" r:id="rId37"/>
-    <p:sldId id="327" r:id="rId38"/>
-    <p:sldId id="284" r:id="rId39"/>
+    <p:sldId id="261" r:id="rId12"/>
+    <p:sldId id="308" r:id="rId13"/>
+    <p:sldId id="334" r:id="rId14"/>
+    <p:sldId id="328" r:id="rId15"/>
+    <p:sldId id="309" r:id="rId16"/>
+    <p:sldId id="310" r:id="rId17"/>
+    <p:sldId id="311" r:id="rId18"/>
+    <p:sldId id="312" r:id="rId19"/>
+    <p:sldId id="314" r:id="rId20"/>
+    <p:sldId id="317" r:id="rId21"/>
+    <p:sldId id="315" r:id="rId22"/>
+    <p:sldId id="300" r:id="rId23"/>
+    <p:sldId id="318" r:id="rId24"/>
+    <p:sldId id="319" r:id="rId25"/>
+    <p:sldId id="321" r:id="rId26"/>
+    <p:sldId id="320" r:id="rId27"/>
+    <p:sldId id="322" r:id="rId28"/>
+    <p:sldId id="323" r:id="rId29"/>
+    <p:sldId id="324" r:id="rId30"/>
+    <p:sldId id="329" r:id="rId31"/>
+    <p:sldId id="330" r:id="rId32"/>
+    <p:sldId id="331" r:id="rId33"/>
+    <p:sldId id="325" r:id="rId34"/>
+    <p:sldId id="326" r:id="rId35"/>
+    <p:sldId id="335" r:id="rId36"/>
+    <p:sldId id="327" r:id="rId37"/>
+    <p:sldId id="284" r:id="rId38"/>
   </p:sldIdLst>
   <p:sldSz cx="9144000" cy="6858000" type="screen4x3"/>
   <p:notesSz cx="7559675" cy="10691813"/>
@@ -147,7 +146,7 @@
 <file path=ppt/revisionInfo.xml><?xml version="1.0" encoding="utf-8"?>
 <p1510:revInfo xmlns:a="http://schemas.openxmlformats.org/drawingml/2006/main" xmlns:r="http://schemas.openxmlformats.org/officeDocument/2006/relationships" xmlns:p1510="http://schemas.microsoft.com/office/powerpoint/2015/10/main">
   <p1510:revLst>
-    <p1510:client id="{C78DE78A-4FC3-2949-B578-22512952A247}" v="3" dt="2026-04-27T18:29:44.125"/>
+    <p1510:client id="{C34381CA-D275-7A70-1E00-B8C5CA8D1FA5}" v="1" dt="2026-05-19T11:52:20.181"/>
   </p1510:revLst>
 </p1510:revInfo>
 </file>
@@ -6985,400 +6984,6 @@
   <p:cSld>
     <p:spTree>
       <p:nvGrpSpPr>
-        <p:cNvPr id="1" name="">
-          <a:extLst>
-            <a:ext uri="{FF2B5EF4-FFF2-40B4-BE49-F238E27FC236}">
-              <a16:creationId xmlns:a16="http://schemas.microsoft.com/office/drawing/2014/main" id="{268468A0-34E1-197D-10CF-E05A5A65E85C}"/>
-            </a:ext>
-          </a:extLst>
-        </p:cNvPr>
-        <p:cNvGrpSpPr/>
-        <p:nvPr/>
-      </p:nvGrpSpPr>
-      <p:grpSpPr>
-        <a:xfrm>
-          <a:off x="0" y="0"/>
-          <a:ext cx="0" cy="0"/>
-          <a:chOff x="0" y="0"/>
-          <a:chExt cx="0" cy="0"/>
-        </a:xfrm>
-      </p:grpSpPr>
-      <p:sp>
-        <p:nvSpPr>
-          <p:cNvPr id="174" name="PlaceHolder 1">
-            <a:extLst>
-              <a:ext uri="{FF2B5EF4-FFF2-40B4-BE49-F238E27FC236}">
-                <a16:creationId xmlns:a16="http://schemas.microsoft.com/office/drawing/2014/main" id="{CEC3D49B-BE22-AF3E-7C53-28B3D99AD3DD}"/>
-              </a:ext>
-            </a:extLst>
-          </p:cNvPr>
-          <p:cNvSpPr>
-            <a:spLocks noGrp="1"/>
-          </p:cNvSpPr>
-          <p:nvPr>
-            <p:ph type="title"/>
-          </p:nvPr>
-        </p:nvSpPr>
-        <p:spPr>
-          <a:xfrm>
-            <a:off x="684000" y="584640"/>
-            <a:ext cx="5744880" cy="558000"/>
-          </a:xfrm>
-          <a:prstGeom prst="rect">
-            <a:avLst/>
-          </a:prstGeom>
-          <a:noFill/>
-          <a:ln w="0">
-            <a:noFill/>
-          </a:ln>
-        </p:spPr>
-        <p:txBody>
-          <a:bodyPr lIns="0" tIns="0" rIns="0" bIns="0" anchor="t">
-            <a:noAutofit/>
-          </a:bodyPr>
-          <a:lstStyle/>
-          <a:p>
-            <a:pPr>
-              <a:lnSpc>
-                <a:spcPct val="100000"/>
-              </a:lnSpc>
-            </a:pPr>
-            <a:r>
-              <a:rPr lang="de-DE" sz="3000" b="1" spc="-1">
-                <a:solidFill>
-                  <a:srgbClr val="003056"/>
-                </a:solidFill>
-                <a:latin typeface="Calibri"/>
-              </a:rPr>
-              <a:t>But First...</a:t>
-            </a:r>
-            <a:endParaRPr lang="en-US"/>
-          </a:p>
-        </p:txBody>
-      </p:sp>
-      <p:sp>
-        <p:nvSpPr>
-          <p:cNvPr id="175" name="PlaceHolder 2">
-            <a:extLst>
-              <a:ext uri="{FF2B5EF4-FFF2-40B4-BE49-F238E27FC236}">
-                <a16:creationId xmlns:a16="http://schemas.microsoft.com/office/drawing/2014/main" id="{56B04F27-5F33-2DED-924D-EA26BCB2918A}"/>
-              </a:ext>
-            </a:extLst>
-          </p:cNvPr>
-          <p:cNvSpPr>
-            <a:spLocks noGrp="1"/>
-          </p:cNvSpPr>
-          <p:nvPr>
-            <p:ph type="ftr" idx="31"/>
-          </p:nvPr>
-        </p:nvSpPr>
-        <p:spPr>
-          <a:xfrm>
-            <a:off x="684000" y="6134400"/>
-            <a:ext cx="2895120" cy="179640"/>
-          </a:xfrm>
-          <a:prstGeom prst="rect">
-            <a:avLst/>
-          </a:prstGeom>
-          <a:noFill/>
-          <a:ln w="0">
-            <a:noFill/>
-          </a:ln>
-        </p:spPr>
-        <p:txBody>
-          <a:bodyPr lIns="0" tIns="0" rIns="0" bIns="0" anchor="t">
-            <a:noAutofit/>
-          </a:bodyPr>
-          <a:lstStyle>
-            <a:lvl1pPr>
-              <a:lnSpc>
-                <a:spcPct val="100000"/>
-              </a:lnSpc>
-              <a:buNone/>
-              <a:defRPr lang="de-DE" sz="1200" b="0" strike="noStrike" spc="-1">
-                <a:solidFill>
-                  <a:srgbClr val="003056"/>
-                </a:solidFill>
-                <a:latin typeface="Calibri"/>
-              </a:defRPr>
-            </a:lvl1pPr>
-          </a:lstStyle>
-          <a:p>
-            <a:pPr>
-              <a:lnSpc>
-                <a:spcPct val="100000"/>
-              </a:lnSpc>
-              <a:buNone/>
-            </a:pPr>
-            <a:r>
-              <a:rPr lang="de-DE" sz="1200" b="0" strike="noStrike" spc="-1">
-                <a:solidFill>
-                  <a:srgbClr val="003056"/>
-                </a:solidFill>
-                <a:latin typeface="Calibri"/>
-              </a:rPr>
-              <a:t>Dr. Daniel Ruffinelli - FSS 2026</a:t>
-            </a:r>
-            <a:endParaRPr lang="en-US" sz="1200" b="0" strike="noStrike" spc="-1">
-              <a:latin typeface="Times New Roman"/>
-            </a:endParaRPr>
-          </a:p>
-        </p:txBody>
-      </p:sp>
-      <p:sp>
-        <p:nvSpPr>
-          <p:cNvPr id="176" name="PlaceHolder 3">
-            <a:extLst>
-              <a:ext uri="{FF2B5EF4-FFF2-40B4-BE49-F238E27FC236}">
-                <a16:creationId xmlns:a16="http://schemas.microsoft.com/office/drawing/2014/main" id="{59B626DB-41C1-6E81-1185-04CBD67C8CF0}"/>
-              </a:ext>
-            </a:extLst>
-          </p:cNvPr>
-          <p:cNvSpPr>
-            <a:spLocks noGrp="1"/>
-          </p:cNvSpPr>
-          <p:nvPr>
-            <p:ph/>
-          </p:nvPr>
-        </p:nvSpPr>
-        <p:spPr>
-          <a:xfrm>
-            <a:off x="684000" y="1143000"/>
-            <a:ext cx="7775640" cy="4673160"/>
-          </a:xfrm>
-          <a:prstGeom prst="rect">
-            <a:avLst/>
-          </a:prstGeom>
-          <a:noFill/>
-          <a:ln w="0">
-            <a:noFill/>
-          </a:ln>
-        </p:spPr>
-        <p:txBody>
-          <a:bodyPr lIns="0" tIns="0" rIns="0" bIns="0" anchor="t">
-            <a:noAutofit/>
-          </a:bodyPr>
-          <a:lstStyle/>
-          <a:p>
-            <a:pPr marL="342900" indent="-342900">
-              <a:lnSpc>
-                <a:spcPct val="100000"/>
-              </a:lnSpc>
-              <a:spcBef>
-                <a:spcPts val="400"/>
-              </a:spcBef>
-              <a:buClr>
-                <a:srgbClr val="003056"/>
-              </a:buClr>
-              <a:buFont typeface="Arial"/>
-              <a:buChar char="•"/>
-            </a:pPr>
-            <a:r>
-              <a:rPr lang="en-US" sz="2000" spc="-1">
-                <a:solidFill>
-                  <a:srgbClr val="003056"/>
-                </a:solidFill>
-                <a:latin typeface="Calibri"/>
-              </a:rPr>
-              <a:t>Please evaluate our course!</a:t>
-            </a:r>
-            <a:endParaRPr lang="en-US" sz="2000" spc="-1" dirty="0">
-              <a:solidFill>
-                <a:srgbClr val="003056"/>
-              </a:solidFill>
-              <a:latin typeface="Calibri"/>
-            </a:endParaRPr>
-          </a:p>
-        </p:txBody>
-      </p:sp>
-      <p:sp>
-        <p:nvSpPr>
-          <p:cNvPr id="5" name="PlaceHolder 4">
-            <a:extLst>
-              <a:ext uri="{FF2B5EF4-FFF2-40B4-BE49-F238E27FC236}">
-                <a16:creationId xmlns:a16="http://schemas.microsoft.com/office/drawing/2014/main" id="{EE217250-21CD-2FDE-B1BC-C38FB8326AAA}"/>
-              </a:ext>
-            </a:extLst>
-          </p:cNvPr>
-          <p:cNvSpPr>
-            <a:spLocks noGrp="1"/>
-          </p:cNvSpPr>
-          <p:nvPr>
-            <p:ph type="sldNum" idx="6"/>
-          </p:nvPr>
-        </p:nvSpPr>
-        <p:spPr/>
-        <p:txBody>
-          <a:bodyPr/>
-          <a:lstStyle/>
-          <a:p>
-            <a:fld id="{DB375770-8B97-4210-92C0-B7AB3E1F40BE}" type="slidenum">
-              <a:t>10</a:t>
-            </a:fld>
-            <a:endParaRPr/>
-          </a:p>
-        </p:txBody>
-      </p:sp>
-      <p:pic>
-        <p:nvPicPr>
-          <p:cNvPr id="2" name="Picture 1">
-            <a:extLst>
-              <a:ext uri="{FF2B5EF4-FFF2-40B4-BE49-F238E27FC236}">
-                <a16:creationId xmlns:a16="http://schemas.microsoft.com/office/drawing/2014/main" id="{E5C8F7CA-B47A-E3A0-F7D9-3AA5E874CAD2}"/>
-              </a:ext>
-            </a:extLst>
-          </p:cNvPr>
-          <p:cNvPicPr>
-            <a:picLocks noChangeAspect="1"/>
-          </p:cNvPicPr>
-          <p:nvPr/>
-        </p:nvPicPr>
-        <p:blipFill>
-          <a:blip r:embed="rId2"/>
-          <a:stretch>
-            <a:fillRect/>
-          </a:stretch>
-        </p:blipFill>
-        <p:spPr>
-          <a:xfrm>
-            <a:off x="2533930" y="1626254"/>
-            <a:ext cx="4084545" cy="4084545"/>
-          </a:xfrm>
-          <a:prstGeom prst="rect">
-            <a:avLst/>
-          </a:prstGeom>
-        </p:spPr>
-      </p:pic>
-    </p:spTree>
-    <p:extLst>
-      <p:ext uri="{BB962C8B-B14F-4D97-AF65-F5344CB8AC3E}">
-        <p14:creationId xmlns:p14="http://schemas.microsoft.com/office/powerpoint/2010/main" val="1090841197"/>
-      </p:ext>
-    </p:extLst>
-  </p:cSld>
-  <p:clrMapOvr>
-    <a:masterClrMapping/>
-  </p:clrMapOvr>
-  <p:transition>
-    <p:fade/>
-  </p:transition>
-  <p:timing>
-    <p:tnLst>
-      <p:par>
-        <p:cTn id="1" dur="indefinite" restart="never" nodeType="tmRoot">
-          <p:childTnLst>
-            <p:seq concurrent="1" nextAc="seek">
-              <p:cTn id="2" dur="indefinite" nodeType="mainSeq">
-                <p:childTnLst>
-                  <p:par>
-                    <p:cTn id="3" fill="hold">
-                      <p:stCondLst>
-                        <p:cond delay="indefinite"/>
-                      </p:stCondLst>
-                      <p:childTnLst>
-                        <p:par>
-                          <p:cTn id="4" fill="hold">
-                            <p:stCondLst>
-                              <p:cond delay="0"/>
-                            </p:stCondLst>
-                            <p:childTnLst>
-                              <p:par>
-                                <p:cTn id="5" presetID="1" presetClass="entr" presetSubtype="0" fill="hold" grpId="0" nodeType="clickEffect">
-                                  <p:stCondLst>
-                                    <p:cond delay="0"/>
-                                  </p:stCondLst>
-                                  <p:childTnLst>
-                                    <p:set>
-                                      <p:cBhvr>
-                                        <p:cTn id="6" dur="1" fill="hold">
-                                          <p:stCondLst>
-                                            <p:cond delay="0"/>
-                                          </p:stCondLst>
-                                        </p:cTn>
-                                        <p:tgtEl>
-                                          <p:spTgt spid="176">
-                                            <p:txEl>
-                                              <p:pRg st="0" end="0"/>
-                                            </p:txEl>
-                                          </p:spTgt>
-                                        </p:tgtEl>
-                                        <p:attrNameLst>
-                                          <p:attrName>style.visibility</p:attrName>
-                                        </p:attrNameLst>
-                                      </p:cBhvr>
-                                      <p:to>
-                                        <p:strVal val="visible"/>
-                                      </p:to>
-                                    </p:set>
-                                  </p:childTnLst>
-                                </p:cTn>
-                              </p:par>
-                              <p:par>
-                                <p:cTn id="7" presetID="1" presetClass="entr" presetSubtype="0" fill="hold" nodeType="withEffect">
-                                  <p:stCondLst>
-                                    <p:cond delay="0"/>
-                                  </p:stCondLst>
-                                  <p:childTnLst>
-                                    <p:set>
-                                      <p:cBhvr>
-                                        <p:cTn id="8" dur="1" fill="hold">
-                                          <p:stCondLst>
-                                            <p:cond delay="0"/>
-                                          </p:stCondLst>
-                                        </p:cTn>
-                                        <p:tgtEl>
-                                          <p:spTgt spid="2"/>
-                                        </p:tgtEl>
-                                        <p:attrNameLst>
-                                          <p:attrName>style.visibility</p:attrName>
-                                        </p:attrNameLst>
-                                      </p:cBhvr>
-                                      <p:to>
-                                        <p:strVal val="visible"/>
-                                      </p:to>
-                                    </p:set>
-                                  </p:childTnLst>
-                                </p:cTn>
-                              </p:par>
-                            </p:childTnLst>
-                          </p:cTn>
-                        </p:par>
-                      </p:childTnLst>
-                    </p:cTn>
-                  </p:par>
-                </p:childTnLst>
-              </p:cTn>
-              <p:prevCondLst>
-                <p:cond evt="onPrev" delay="0">
-                  <p:tgtEl>
-                    <p:sldTgt/>
-                  </p:tgtEl>
-                </p:cond>
-              </p:prevCondLst>
-              <p:nextCondLst>
-                <p:cond evt="onNext" delay="0">
-                  <p:tgtEl>
-                    <p:sldTgt/>
-                  </p:tgtEl>
-                </p:cond>
-              </p:nextCondLst>
-            </p:seq>
-          </p:childTnLst>
-        </p:cTn>
-      </p:par>
-    </p:tnLst>
-    <p:bldLst>
-      <p:bldP spid="176" grpId="0" build="p"/>
-    </p:bldLst>
-  </p:timing>
-</p:sld>
-</file>
-
-<file path=ppt/slides/slide11.xml><?xml version="1.0" encoding="utf-8"?>
-<p:sld xmlns:a="http://schemas.openxmlformats.org/drawingml/2006/main" xmlns:r="http://schemas.openxmlformats.org/officeDocument/2006/relationships" xmlns:p="http://schemas.openxmlformats.org/presentationml/2006/main">
-  <p:cSld>
-    <p:spTree>
-      <p:nvGrpSpPr>
         <p:cNvPr id="1" name=""/>
         <p:cNvGrpSpPr/>
         <p:nvPr/>
@@ -7667,7 +7272,7 @@
           <a:lstStyle/>
           <a:p>
             <a:fld id="{5F2B43E7-B823-4A23-841C-33749B8E44AD}" type="slidenum">
-              <a:t>11</a:t>
+              <a:t>10</a:t>
             </a:fld>
             <a:endParaRPr/>
           </a:p>
@@ -7684,7 +7289,7 @@
 </p:sld>
 </file>
 
-<file path=ppt/slides/slide12.xml><?xml version="1.0" encoding="utf-8"?>
+<file path=ppt/slides/slide11.xml><?xml version="1.0" encoding="utf-8"?>
 <p:sld xmlns:a="http://schemas.openxmlformats.org/drawingml/2006/main" xmlns:r="http://schemas.openxmlformats.org/officeDocument/2006/relationships" xmlns:p="http://schemas.openxmlformats.org/presentationml/2006/main">
   <p:cSld>
     <p:spTree>
@@ -8482,7 +8087,7 @@
           <a:lstStyle/>
           <a:p>
             <a:fld id="{AC7497A8-7E1F-45D3-91D1-10848132C468}" type="slidenum">
-              <a:t>12</a:t>
+              <a:t>11</a:t>
             </a:fld>
             <a:endParaRPr/>
           </a:p>
@@ -8932,7 +8537,7 @@
 </p:sld>
 </file>
 
-<file path=ppt/slides/slide13.xml><?xml version="1.0" encoding="utf-8"?>
+<file path=ppt/slides/slide12.xml><?xml version="1.0" encoding="utf-8"?>
 <p:sld xmlns:a="http://schemas.openxmlformats.org/drawingml/2006/main" xmlns:r="http://schemas.openxmlformats.org/officeDocument/2006/relationships" xmlns:p="http://schemas.openxmlformats.org/presentationml/2006/main">
   <p:cSld>
     <p:spTree>
@@ -9790,7 +9395,7 @@
           <a:lstStyle/>
           <a:p>
             <a:fld id="{AC7497A8-7E1F-45D3-91D1-10848132C468}" type="slidenum">
-              <a:t>13</a:t>
+              <a:t>12</a:t>
             </a:fld>
             <a:endParaRPr/>
           </a:p>
@@ -10369,7 +9974,7 @@
 </p:sld>
 </file>
 
-<file path=ppt/slides/slide14.xml><?xml version="1.0" encoding="utf-8"?>
+<file path=ppt/slides/slide13.xml><?xml version="1.0" encoding="utf-8"?>
 <p:sld xmlns:a="http://schemas.openxmlformats.org/drawingml/2006/main" xmlns:r="http://schemas.openxmlformats.org/officeDocument/2006/relationships" xmlns:p="http://schemas.openxmlformats.org/presentationml/2006/main">
   <p:cSld>
     <p:spTree>
@@ -10954,7 +10559,7 @@
           <a:lstStyle/>
           <a:p>
             <a:fld id="{AC7497A8-7E1F-45D3-91D1-10848132C468}" type="slidenum">
-              <a:t>14</a:t>
+              <a:t>13</a:t>
             </a:fld>
             <a:endParaRPr/>
           </a:p>
@@ -11440,7 +11045,7 @@
 </p:sld>
 </file>
 
-<file path=ppt/slides/slide15.xml><?xml version="1.0" encoding="utf-8"?>
+<file path=ppt/slides/slide14.xml><?xml version="1.0" encoding="utf-8"?>
 <p:sld xmlns:a="http://schemas.openxmlformats.org/drawingml/2006/main" xmlns:r="http://schemas.openxmlformats.org/officeDocument/2006/relationships" xmlns:p="http://schemas.openxmlformats.org/presentationml/2006/main">
   <p:cSld>
     <p:spTree>
@@ -11741,7 +11346,7 @@
           <a:lstStyle/>
           <a:p>
             <a:fld id="{AC7497A8-7E1F-45D3-91D1-10848132C468}" type="slidenum">
-              <a:t>15</a:t>
+              <a:t>14</a:t>
             </a:fld>
             <a:endParaRPr/>
           </a:p>
@@ -12020,7 +11625,7 @@
 </p:sld>
 </file>
 
-<file path=ppt/slides/slide16.xml><?xml version="1.0" encoding="utf-8"?>
+<file path=ppt/slides/slide15.xml><?xml version="1.0" encoding="utf-8"?>
 <p:sld xmlns:a="http://schemas.openxmlformats.org/drawingml/2006/main" xmlns:r="http://schemas.openxmlformats.org/officeDocument/2006/relationships" xmlns:p="http://schemas.openxmlformats.org/presentationml/2006/main">
   <p:cSld>
     <p:spTree>
@@ -12308,7 +11913,7 @@
           <a:lstStyle/>
           <a:p>
             <a:fld id="{AC7497A8-7E1F-45D3-91D1-10848132C468}" type="slidenum">
-              <a:t>16</a:t>
+              <a:t>15</a:t>
             </a:fld>
             <a:endParaRPr/>
           </a:p>
@@ -12610,7 +12215,7 @@
 </p:sld>
 </file>
 
-<file path=ppt/slides/slide17.xml><?xml version="1.0" encoding="utf-8"?>
+<file path=ppt/slides/slide16.xml><?xml version="1.0" encoding="utf-8"?>
 <p:sld xmlns:a="http://schemas.openxmlformats.org/drawingml/2006/main" xmlns:r="http://schemas.openxmlformats.org/officeDocument/2006/relationships" xmlns:p="http://schemas.openxmlformats.org/presentationml/2006/main">
   <p:cSld>
     <p:spTree>
@@ -13720,7 +13325,7 @@
           <a:lstStyle/>
           <a:p>
             <a:fld id="{AC7497A8-7E1F-45D3-91D1-10848132C468}" type="slidenum">
-              <a:t>17</a:t>
+              <a:t>16</a:t>
             </a:fld>
             <a:endParaRPr/>
           </a:p>
@@ -14072,7 +13677,7 @@
 </p:sld>
 </file>
 
-<file path=ppt/slides/slide18.xml><?xml version="1.0" encoding="utf-8"?>
+<file path=ppt/slides/slide17.xml><?xml version="1.0" encoding="utf-8"?>
 <p:sld xmlns:a="http://schemas.openxmlformats.org/drawingml/2006/main" xmlns:r="http://schemas.openxmlformats.org/officeDocument/2006/relationships" xmlns:p="http://schemas.openxmlformats.org/presentationml/2006/main">
   <p:cSld>
     <p:spTree>
@@ -15479,7 +15084,7 @@
           <a:lstStyle/>
           <a:p>
             <a:fld id="{AC7497A8-7E1F-45D3-91D1-10848132C468}" type="slidenum">
-              <a:t>18</a:t>
+              <a:t>17</a:t>
             </a:fld>
             <a:endParaRPr/>
           </a:p>
@@ -15947,7 +15552,7 @@
 </p:sld>
 </file>
 
-<file path=ppt/slides/slide19.xml><?xml version="1.0" encoding="utf-8"?>
+<file path=ppt/slides/slide18.xml><?xml version="1.0" encoding="utf-8"?>
 <p:sld xmlns:a="http://schemas.openxmlformats.org/drawingml/2006/main" xmlns:r="http://schemas.openxmlformats.org/officeDocument/2006/relationships" xmlns:p="http://schemas.openxmlformats.org/presentationml/2006/main">
   <p:cSld>
     <p:spTree>
@@ -17219,7 +16824,7 @@
           <a:lstStyle/>
           <a:p>
             <a:fld id="{AC7497A8-7E1F-45D3-91D1-10848132C468}" type="slidenum">
-              <a:t>19</a:t>
+              <a:t>18</a:t>
             </a:fld>
             <a:endParaRPr/>
           </a:p>
@@ -17718,875 +17323,7 @@
 </p:sld>
 </file>
 
-<file path=ppt/slides/slide2.xml><?xml version="1.0" encoding="utf-8"?>
-<p:sld xmlns:a="http://schemas.openxmlformats.org/drawingml/2006/main" xmlns:r="http://schemas.openxmlformats.org/officeDocument/2006/relationships" xmlns:p="http://schemas.openxmlformats.org/presentationml/2006/main">
-  <p:cSld>
-    <p:spTree>
-      <p:nvGrpSpPr>
-        <p:cNvPr id="1" name=""/>
-        <p:cNvGrpSpPr/>
-        <p:nvPr/>
-      </p:nvGrpSpPr>
-      <p:grpSpPr>
-        <a:xfrm>
-          <a:off x="0" y="0"/>
-          <a:ext cx="0" cy="0"/>
-          <a:chOff x="0" y="0"/>
-          <a:chExt cx="0" cy="0"/>
-        </a:xfrm>
-      </p:grpSpPr>
-      <p:sp>
-        <p:nvSpPr>
-          <p:cNvPr id="93" name="PlaceHolder 1"/>
-          <p:cNvSpPr>
-            <a:spLocks noGrp="1"/>
-          </p:cNvSpPr>
-          <p:nvPr>
-            <p:ph type="title"/>
-          </p:nvPr>
-        </p:nvSpPr>
-        <p:spPr>
-          <a:xfrm>
-            <a:off x="684000" y="584640"/>
-            <a:ext cx="5478840" cy="558000"/>
-          </a:xfrm>
-          <a:prstGeom prst="rect">
-            <a:avLst/>
-          </a:prstGeom>
-          <a:noFill/>
-          <a:ln w="0">
-            <a:noFill/>
-          </a:ln>
-        </p:spPr>
-        <p:txBody>
-          <a:bodyPr lIns="0" tIns="0" rIns="0" bIns="0" anchor="t">
-            <a:noAutofit/>
-          </a:bodyPr>
-          <a:lstStyle/>
-          <a:p>
-            <a:pPr>
-              <a:lnSpc>
-                <a:spcPct val="100000"/>
-              </a:lnSpc>
-            </a:pPr>
-            <a:r>
-              <a:rPr lang="de-DE" sz="3000" b="1" spc="-1" dirty="0">
-                <a:solidFill>
-                  <a:srgbClr val="003056"/>
-                </a:solidFill>
-                <a:latin typeface="Calibri"/>
-              </a:rPr>
-              <a:t>Most Spoken </a:t>
-            </a:r>
-            <a:r>
-              <a:rPr lang="de-DE" sz="3000" b="1" spc="-1" dirty="0" err="1">
-                <a:solidFill>
-                  <a:srgbClr val="003056"/>
-                </a:solidFill>
-                <a:latin typeface="Calibri"/>
-              </a:rPr>
-              <a:t>Languages</a:t>
-            </a:r>
-            <a:r>
-              <a:rPr lang="de-DE" sz="3000" b="1" spc="-1" dirty="0">
-                <a:solidFill>
-                  <a:srgbClr val="003056"/>
-                </a:solidFill>
-                <a:latin typeface="Calibri"/>
-              </a:rPr>
-              <a:t> (1)</a:t>
-            </a:r>
-            <a:endParaRPr lang="de-DE" sz="3000" b="0" strike="noStrike" spc="-1" dirty="0" err="1">
-              <a:solidFill>
-                <a:srgbClr val="000000"/>
-              </a:solidFill>
-              <a:latin typeface="Calibri"/>
-            </a:endParaRPr>
-          </a:p>
-        </p:txBody>
-      </p:sp>
-      <p:sp>
-        <p:nvSpPr>
-          <p:cNvPr id="94" name="PlaceHolder 2"/>
-          <p:cNvSpPr>
-            <a:spLocks noGrp="1"/>
-          </p:cNvSpPr>
-          <p:nvPr>
-            <p:ph type="ftr" idx="9"/>
-          </p:nvPr>
-        </p:nvSpPr>
-        <p:spPr>
-          <a:xfrm>
-            <a:off x="684000" y="6134400"/>
-            <a:ext cx="2895120" cy="179640"/>
-          </a:xfrm>
-          <a:prstGeom prst="rect">
-            <a:avLst/>
-          </a:prstGeom>
-          <a:noFill/>
-          <a:ln w="0">
-            <a:noFill/>
-          </a:ln>
-        </p:spPr>
-        <p:txBody>
-          <a:bodyPr lIns="0" tIns="0" rIns="0" bIns="0" anchor="t">
-            <a:noAutofit/>
-          </a:bodyPr>
-          <a:lstStyle>
-            <a:lvl1pPr>
-              <a:lnSpc>
-                <a:spcPct val="100000"/>
-              </a:lnSpc>
-              <a:buNone/>
-              <a:defRPr lang="de-DE" sz="1200" b="0" strike="noStrike" spc="-1">
-                <a:solidFill>
-                  <a:srgbClr val="003056"/>
-                </a:solidFill>
-                <a:latin typeface="Calibri"/>
-              </a:defRPr>
-            </a:lvl1pPr>
-          </a:lstStyle>
-          <a:p>
-            <a:pPr>
-              <a:lnSpc>
-                <a:spcPct val="100000"/>
-              </a:lnSpc>
-              <a:buNone/>
-            </a:pPr>
-            <a:r>
-              <a:rPr lang="de-DE" sz="1200" b="0" strike="noStrike" spc="-1" dirty="0">
-                <a:solidFill>
-                  <a:srgbClr val="003056"/>
-                </a:solidFill>
-                <a:latin typeface="Calibri"/>
-              </a:rPr>
-              <a:t>Dr. Daniel Ruffinelli - FSS 2026</a:t>
-            </a:r>
-            <a:endParaRPr lang="en-US" sz="1200" b="0" strike="noStrike" spc="-1" dirty="0">
-              <a:latin typeface="Times New Roman"/>
-            </a:endParaRPr>
-          </a:p>
-        </p:txBody>
-      </p:sp>
-      <p:sp>
-        <p:nvSpPr>
-          <p:cNvPr id="95" name="PlaceHolder 3"/>
-          <p:cNvSpPr>
-            <a:spLocks noGrp="1"/>
-          </p:cNvSpPr>
-          <p:nvPr>
-            <p:ph/>
-          </p:nvPr>
-        </p:nvSpPr>
-        <p:spPr>
-          <a:xfrm>
-            <a:off x="684000" y="1143000"/>
-            <a:ext cx="7775640" cy="4903603"/>
-          </a:xfrm>
-          <a:prstGeom prst="rect">
-            <a:avLst/>
-          </a:prstGeom>
-          <a:noFill/>
-          <a:ln w="0">
-            <a:noFill/>
-          </a:ln>
-        </p:spPr>
-        <p:txBody>
-          <a:bodyPr lIns="0" tIns="0" rIns="0" bIns="0" anchor="t">
-            <a:noAutofit/>
-          </a:bodyPr>
-          <a:lstStyle/>
-          <a:p>
-            <a:pPr marL="285750">
-              <a:lnSpc>
-                <a:spcPct val="100000"/>
-              </a:lnSpc>
-              <a:spcBef>
-                <a:spcPts val="360"/>
-              </a:spcBef>
-              <a:buClr>
-                <a:srgbClr val="003056"/>
-              </a:buClr>
-              <a:buFont typeface="Arial"/>
-              <a:buChar char="•"/>
-            </a:pPr>
-            <a:r>
-              <a:rPr lang="en-US" sz="2000" spc="-1" dirty="0">
-                <a:solidFill>
-                  <a:srgbClr val="003056"/>
-                </a:solidFill>
-                <a:latin typeface="Calibri"/>
-              </a:rPr>
-              <a:t>What are the most spoken languages in the world?</a:t>
-            </a:r>
-          </a:p>
-          <a:p>
-            <a:pPr marL="742950" lvl="1">
-              <a:lnSpc>
-                <a:spcPct val="100000"/>
-              </a:lnSpc>
-              <a:spcBef>
-                <a:spcPts val="360"/>
-              </a:spcBef>
-              <a:buClr>
-                <a:srgbClr val="003056"/>
-              </a:buClr>
-              <a:buFont typeface="Arial"/>
-              <a:buChar char="•"/>
-            </a:pPr>
-            <a:r>
-              <a:rPr lang="en-US" sz="1800" spc="-1" dirty="0">
-                <a:solidFill>
-                  <a:srgbClr val="003056"/>
-                </a:solidFill>
-                <a:latin typeface="Calibri"/>
-                <a:ea typeface="Calibri"/>
-                <a:cs typeface="Calibri"/>
-              </a:rPr>
-              <a:t>According to </a:t>
-            </a:r>
-            <a:r>
-              <a:rPr lang="en-US" sz="1800" spc="-1" dirty="0">
-                <a:solidFill>
-                  <a:srgbClr val="003056"/>
-                </a:solidFill>
-                <a:latin typeface="Calibri"/>
-                <a:ea typeface="Calibri"/>
-                <a:cs typeface="Calibri"/>
-                <a:hlinkClick r:id="rId2"/>
-              </a:rPr>
-              <a:t>Ethnologue</a:t>
-            </a:r>
-            <a:r>
-              <a:rPr lang="en-US" sz="1800" spc="-1" dirty="0">
-                <a:solidFill>
-                  <a:srgbClr val="003056"/>
-                </a:solidFill>
-                <a:latin typeface="Calibri"/>
-                <a:ea typeface="Calibri"/>
-                <a:cs typeface="Calibri"/>
-              </a:rPr>
-              <a:t>, this is the distribution for </a:t>
-            </a:r>
-            <a:r>
-              <a:rPr lang="en-US" sz="1800" i="1" spc="-1" dirty="0">
-                <a:solidFill>
-                  <a:srgbClr val="003056"/>
-                </a:solidFill>
-                <a:latin typeface="Calibri"/>
-                <a:ea typeface="Calibri"/>
-                <a:cs typeface="Calibri"/>
-              </a:rPr>
-              <a:t>native</a:t>
-            </a:r>
-            <a:r>
-              <a:rPr lang="en-US" sz="1800" spc="-1" dirty="0">
-                <a:solidFill>
-                  <a:srgbClr val="003056"/>
-                </a:solidFill>
-                <a:latin typeface="Calibri"/>
-                <a:ea typeface="Calibri"/>
-                <a:cs typeface="Calibri"/>
-              </a:rPr>
-              <a:t> speakers</a:t>
-            </a:r>
-          </a:p>
-          <a:p>
-            <a:pPr marL="742950" lvl="1">
-              <a:lnSpc>
-                <a:spcPct val="100000"/>
-              </a:lnSpc>
-              <a:spcBef>
-                <a:spcPts val="360"/>
-              </a:spcBef>
-              <a:buClr>
-                <a:srgbClr val="003056"/>
-              </a:buClr>
-              <a:buFont typeface="Arial"/>
-              <a:buChar char="•"/>
-            </a:pPr>
-            <a:endParaRPr lang="en-US" sz="1800" spc="-1" dirty="0">
-              <a:solidFill>
-                <a:srgbClr val="003056"/>
-              </a:solidFill>
-              <a:latin typeface="Calibri"/>
-              <a:ea typeface="Calibri"/>
-              <a:cs typeface="Calibri"/>
-            </a:endParaRPr>
-          </a:p>
-          <a:p>
-            <a:pPr marL="742950" lvl="1">
-              <a:lnSpc>
-                <a:spcPct val="100000"/>
-              </a:lnSpc>
-              <a:spcBef>
-                <a:spcPts val="360"/>
-              </a:spcBef>
-              <a:buClr>
-                <a:srgbClr val="003056"/>
-              </a:buClr>
-              <a:buFont typeface="Arial"/>
-              <a:buChar char="•"/>
-            </a:pPr>
-            <a:endParaRPr lang="en-US" sz="1800" spc="-1" dirty="0">
-              <a:solidFill>
-                <a:srgbClr val="003056"/>
-              </a:solidFill>
-              <a:latin typeface="Calibri"/>
-              <a:ea typeface="Calibri"/>
-              <a:cs typeface="Calibri"/>
-            </a:endParaRPr>
-          </a:p>
-          <a:p>
-            <a:pPr marL="742950" lvl="1">
-              <a:lnSpc>
-                <a:spcPct val="100000"/>
-              </a:lnSpc>
-              <a:spcBef>
-                <a:spcPts val="360"/>
-              </a:spcBef>
-              <a:buClr>
-                <a:srgbClr val="003056"/>
-              </a:buClr>
-              <a:buFont typeface="Arial"/>
-              <a:buChar char="•"/>
-            </a:pPr>
-            <a:endParaRPr lang="en-US" sz="1800" spc="-1" dirty="0">
-              <a:solidFill>
-                <a:srgbClr val="003056"/>
-              </a:solidFill>
-              <a:latin typeface="Calibri"/>
-              <a:ea typeface="Calibri"/>
-              <a:cs typeface="Calibri"/>
-            </a:endParaRPr>
-          </a:p>
-          <a:p>
-            <a:pPr marL="285750">
-              <a:lnSpc>
-                <a:spcPct val="100000"/>
-              </a:lnSpc>
-              <a:spcBef>
-                <a:spcPts val="360"/>
-              </a:spcBef>
-              <a:buClr>
-                <a:srgbClr val="003056"/>
-              </a:buClr>
-              <a:buFont typeface="Arial"/>
-              <a:buChar char="•"/>
-            </a:pPr>
-            <a:endParaRPr lang="en-US" sz="2200" spc="-1" dirty="0">
-              <a:solidFill>
-                <a:srgbClr val="003056"/>
-              </a:solidFill>
-              <a:latin typeface="Calibri"/>
-              <a:ea typeface="Calibri"/>
-              <a:cs typeface="Calibri"/>
-            </a:endParaRPr>
-          </a:p>
-          <a:p>
-            <a:pPr marL="285750">
-              <a:lnSpc>
-                <a:spcPct val="100000"/>
-              </a:lnSpc>
-              <a:spcBef>
-                <a:spcPts val="360"/>
-              </a:spcBef>
-              <a:buClr>
-                <a:srgbClr val="003056"/>
-              </a:buClr>
-              <a:buFont typeface="Arial"/>
-              <a:buChar char="•"/>
-            </a:pPr>
-            <a:endParaRPr lang="en-US" sz="2200" spc="-1" dirty="0">
-              <a:solidFill>
-                <a:srgbClr val="003056"/>
-              </a:solidFill>
-              <a:latin typeface="Calibri"/>
-              <a:ea typeface="Calibri"/>
-              <a:cs typeface="Calibri"/>
-            </a:endParaRPr>
-          </a:p>
-          <a:p>
-            <a:pPr marL="285750">
-              <a:lnSpc>
-                <a:spcPct val="100000"/>
-              </a:lnSpc>
-              <a:spcBef>
-                <a:spcPts val="360"/>
-              </a:spcBef>
-              <a:buClr>
-                <a:srgbClr val="003056"/>
-              </a:buClr>
-              <a:buFont typeface="Arial"/>
-              <a:buChar char="•"/>
-            </a:pPr>
-            <a:endParaRPr lang="en-US" sz="2200" spc="-1" dirty="0">
-              <a:solidFill>
-                <a:srgbClr val="003056"/>
-              </a:solidFill>
-              <a:latin typeface="Calibri"/>
-              <a:ea typeface="Calibri"/>
-              <a:cs typeface="Calibri"/>
-            </a:endParaRPr>
-          </a:p>
-          <a:p>
-            <a:pPr marL="285750">
-              <a:lnSpc>
-                <a:spcPct val="100000"/>
-              </a:lnSpc>
-              <a:spcBef>
-                <a:spcPts val="360"/>
-              </a:spcBef>
-              <a:buClr>
-                <a:srgbClr val="003056"/>
-              </a:buClr>
-              <a:buFont typeface="Arial"/>
-              <a:buChar char="•"/>
-            </a:pPr>
-            <a:endParaRPr lang="en-US" sz="2200" spc="-1" dirty="0">
-              <a:solidFill>
-                <a:srgbClr val="003056"/>
-              </a:solidFill>
-              <a:latin typeface="Calibri"/>
-              <a:ea typeface="Calibri"/>
-              <a:cs typeface="Calibri"/>
-            </a:endParaRPr>
-          </a:p>
-          <a:p>
-            <a:pPr marL="285750">
-              <a:lnSpc>
-                <a:spcPct val="100000"/>
-              </a:lnSpc>
-              <a:spcBef>
-                <a:spcPts val="360"/>
-              </a:spcBef>
-              <a:buClr>
-                <a:srgbClr val="003056"/>
-              </a:buClr>
-              <a:buFont typeface="Arial"/>
-              <a:buChar char="•"/>
-            </a:pPr>
-            <a:endParaRPr lang="en-US" sz="2200" spc="-1" dirty="0">
-              <a:solidFill>
-                <a:srgbClr val="003056"/>
-              </a:solidFill>
-              <a:latin typeface="Calibri"/>
-              <a:ea typeface="Calibri"/>
-              <a:cs typeface="Calibri"/>
-            </a:endParaRPr>
-          </a:p>
-          <a:p>
-            <a:pPr marL="285750">
-              <a:lnSpc>
-                <a:spcPct val="100000"/>
-              </a:lnSpc>
-              <a:spcBef>
-                <a:spcPts val="360"/>
-              </a:spcBef>
-              <a:buClr>
-                <a:srgbClr val="003056"/>
-              </a:buClr>
-              <a:buFont typeface="Arial"/>
-              <a:buChar char="•"/>
-            </a:pPr>
-            <a:endParaRPr lang="en-US" sz="2200" spc="-1" dirty="0">
-              <a:solidFill>
-                <a:srgbClr val="003056"/>
-              </a:solidFill>
-              <a:latin typeface="Calibri"/>
-              <a:ea typeface="Calibri"/>
-              <a:cs typeface="Calibri"/>
-            </a:endParaRPr>
-          </a:p>
-          <a:p>
-            <a:pPr marL="285750">
-              <a:lnSpc>
-                <a:spcPct val="100000"/>
-              </a:lnSpc>
-              <a:spcBef>
-                <a:spcPts val="360"/>
-              </a:spcBef>
-              <a:buClr>
-                <a:srgbClr val="003056"/>
-              </a:buClr>
-              <a:buFont typeface="Arial"/>
-              <a:buChar char="•"/>
-            </a:pPr>
-            <a:endParaRPr lang="en-US" sz="2200" spc="-1" dirty="0">
-              <a:solidFill>
-                <a:srgbClr val="003056"/>
-              </a:solidFill>
-              <a:latin typeface="Calibri"/>
-              <a:ea typeface="Calibri"/>
-              <a:cs typeface="Calibri"/>
-            </a:endParaRPr>
-          </a:p>
-          <a:p>
-            <a:pPr marL="285750">
-              <a:lnSpc>
-                <a:spcPct val="100000"/>
-              </a:lnSpc>
-              <a:spcBef>
-                <a:spcPts val="360"/>
-              </a:spcBef>
-              <a:buClr>
-                <a:srgbClr val="003056"/>
-              </a:buClr>
-              <a:buFont typeface="Arial"/>
-              <a:buChar char="•"/>
-            </a:pPr>
-            <a:r>
-              <a:rPr lang="en-US" sz="2000" spc="-1" dirty="0">
-                <a:solidFill>
-                  <a:srgbClr val="003056"/>
-                </a:solidFill>
-                <a:latin typeface="Calibri"/>
-                <a:ea typeface="Calibri"/>
-                <a:cs typeface="Calibri"/>
-              </a:rPr>
-              <a:t>The top 10 languages cover 3 billion people (37.5% of the world)</a:t>
-            </a:r>
-            <a:endParaRPr lang="en-US" sz="2200" spc="-1" dirty="0">
-              <a:solidFill>
-                <a:srgbClr val="003056"/>
-              </a:solidFill>
-              <a:latin typeface="Calibri"/>
-              <a:ea typeface="Calibri"/>
-              <a:cs typeface="Calibri"/>
-            </a:endParaRPr>
-          </a:p>
-        </p:txBody>
-      </p:sp>
-      <p:sp>
-        <p:nvSpPr>
-          <p:cNvPr id="5" name="PlaceHolder 4"/>
-          <p:cNvSpPr>
-            <a:spLocks noGrp="1"/>
-          </p:cNvSpPr>
-          <p:nvPr>
-            <p:ph type="sldNum" idx="6"/>
-          </p:nvPr>
-        </p:nvSpPr>
-        <p:spPr/>
-        <p:txBody>
-          <a:bodyPr/>
-          <a:lstStyle/>
-          <a:p>
-            <a:fld id="{AC7497A8-7E1F-45D3-91D1-10848132C468}" type="slidenum">
-              <a:t>2</a:t>
-            </a:fld>
-            <a:endParaRPr/>
-          </a:p>
-        </p:txBody>
-      </p:sp>
-      <p:pic>
-        <p:nvPicPr>
-          <p:cNvPr id="4" name="Picture 3" descr="A screenshot of a screen shot&#10;&#10;Description automatically generated">
-            <a:extLst>
-              <a:ext uri="{FF2B5EF4-FFF2-40B4-BE49-F238E27FC236}">
-                <a16:creationId xmlns:a16="http://schemas.microsoft.com/office/drawing/2014/main" id="{3E4BF857-653A-30ED-374C-BA3E3DCAB4A8}"/>
-              </a:ext>
-            </a:extLst>
-          </p:cNvPr>
-          <p:cNvPicPr>
-            <a:picLocks noChangeAspect="1"/>
-          </p:cNvPicPr>
-          <p:nvPr/>
-        </p:nvPicPr>
-        <p:blipFill>
-          <a:blip r:embed="rId3"/>
-          <a:stretch>
-            <a:fillRect/>
-          </a:stretch>
-        </p:blipFill>
-        <p:spPr>
-          <a:xfrm>
-            <a:off x="1479734" y="1871206"/>
-            <a:ext cx="6194016" cy="3447578"/>
-          </a:xfrm>
-          <a:prstGeom prst="rect">
-            <a:avLst/>
-          </a:prstGeom>
-        </p:spPr>
-      </p:pic>
-      <p:sp>
-        <p:nvSpPr>
-          <p:cNvPr id="6" name="TextBox 5">
-            <a:extLst>
-              <a:ext uri="{FF2B5EF4-FFF2-40B4-BE49-F238E27FC236}">
-                <a16:creationId xmlns:a16="http://schemas.microsoft.com/office/drawing/2014/main" id="{823C1546-E861-58AB-52F9-BB33BE414C31}"/>
-              </a:ext>
-            </a:extLst>
-          </p:cNvPr>
-          <p:cNvSpPr txBox="1"/>
-          <p:nvPr/>
-        </p:nvSpPr>
-        <p:spPr>
-          <a:xfrm>
-            <a:off x="7673750" y="5017817"/>
-            <a:ext cx="1176199" cy="307777"/>
-          </a:xfrm>
-          <a:prstGeom prst="rect">
-            <a:avLst/>
-          </a:prstGeom>
-          <a:noFill/>
-        </p:spPr>
-        <p:txBody>
-          <a:bodyPr rot="0" spcFirstLastPara="0" vertOverflow="overflow" horzOverflow="overflow" vert="horz" wrap="square" lIns="91440" tIns="45720" rIns="91440" bIns="45720" numCol="1" spcCol="0" rtlCol="0" fromWordArt="0" anchor="t" anchorCtr="0" forceAA="0" compatLnSpc="1">
-            <a:prstTxWarp prst="textNoShape">
-              <a:avLst/>
-            </a:prstTxWarp>
-            <a:spAutoFit/>
-          </a:bodyPr>
-          <a:lstStyle/>
-          <a:p>
-            <a:r>
-              <a:rPr lang="en-US" sz="1400" dirty="0">
-                <a:latin typeface="Calibri"/>
-                <a:hlinkClick r:id="rId4"/>
-              </a:rPr>
-              <a:t>Image source</a:t>
-            </a:r>
-            <a:endParaRPr lang="en-US" sz="1400" dirty="0">
-              <a:latin typeface="Calibri"/>
-            </a:endParaRPr>
-          </a:p>
-        </p:txBody>
-      </p:sp>
-    </p:spTree>
-    <p:extLst>
-      <p:ext uri="{BB962C8B-B14F-4D97-AF65-F5344CB8AC3E}">
-        <p14:creationId xmlns:p14="http://schemas.microsoft.com/office/powerpoint/2010/main" val="654399792"/>
-      </p:ext>
-    </p:extLst>
-  </p:cSld>
-  <p:clrMapOvr>
-    <a:masterClrMapping/>
-  </p:clrMapOvr>
-  <p:transition>
-    <p:fade/>
-  </p:transition>
-  <p:timing>
-    <p:tnLst>
-      <p:par>
-        <p:cTn id="1" dur="indefinite" restart="never" nodeType="tmRoot">
-          <p:childTnLst>
-            <p:seq concurrent="1" nextAc="seek">
-              <p:cTn id="2" dur="indefinite" nodeType="mainSeq">
-                <p:childTnLst>
-                  <p:par>
-                    <p:cTn id="3" fill="hold">
-                      <p:stCondLst>
-                        <p:cond delay="indefinite"/>
-                      </p:stCondLst>
-                      <p:childTnLst>
-                        <p:par>
-                          <p:cTn id="4" fill="hold">
-                            <p:stCondLst>
-                              <p:cond delay="0"/>
-                            </p:stCondLst>
-                            <p:childTnLst>
-                              <p:par>
-                                <p:cTn id="5" presetID="1" presetClass="entr" presetSubtype="0" fill="hold" grpId="0" nodeType="clickEffect">
-                                  <p:stCondLst>
-                                    <p:cond delay="0"/>
-                                  </p:stCondLst>
-                                  <p:childTnLst>
-                                    <p:set>
-                                      <p:cBhvr>
-                                        <p:cTn id="6" dur="1" fill="hold">
-                                          <p:stCondLst>
-                                            <p:cond delay="0"/>
-                                          </p:stCondLst>
-                                        </p:cTn>
-                                        <p:tgtEl>
-                                          <p:spTgt spid="95">
-                                            <p:txEl>
-                                              <p:pRg st="0" end="0"/>
-                                            </p:txEl>
-                                          </p:spTgt>
-                                        </p:tgtEl>
-                                        <p:attrNameLst>
-                                          <p:attrName>style.visibility</p:attrName>
-                                        </p:attrNameLst>
-                                      </p:cBhvr>
-                                      <p:to>
-                                        <p:strVal val="visible"/>
-                                      </p:to>
-                                    </p:set>
-                                  </p:childTnLst>
-                                </p:cTn>
-                              </p:par>
-                              <p:par>
-                                <p:cTn id="7" presetID="1" presetClass="entr" presetSubtype="0" fill="hold" grpId="0" nodeType="withEffect">
-                                  <p:stCondLst>
-                                    <p:cond delay="0"/>
-                                  </p:stCondLst>
-                                  <p:childTnLst>
-                                    <p:set>
-                                      <p:cBhvr>
-                                        <p:cTn id="8" dur="1" fill="hold">
-                                          <p:stCondLst>
-                                            <p:cond delay="0"/>
-                                          </p:stCondLst>
-                                        </p:cTn>
-                                        <p:tgtEl>
-                                          <p:spTgt spid="95">
-                                            <p:txEl>
-                                              <p:pRg st="1" end="1"/>
-                                            </p:txEl>
-                                          </p:spTgt>
-                                        </p:tgtEl>
-                                        <p:attrNameLst>
-                                          <p:attrName>style.visibility</p:attrName>
-                                        </p:attrNameLst>
-                                      </p:cBhvr>
-                                      <p:to>
-                                        <p:strVal val="visible"/>
-                                      </p:to>
-                                    </p:set>
-                                  </p:childTnLst>
-                                </p:cTn>
-                              </p:par>
-                              <p:par>
-                                <p:cTn id="9" presetID="1" presetClass="entr" presetSubtype="0" fill="hold" nodeType="withEffect">
-                                  <p:stCondLst>
-                                    <p:cond delay="0"/>
-                                  </p:stCondLst>
-                                  <p:childTnLst>
-                                    <p:set>
-                                      <p:cBhvr>
-                                        <p:cTn id="10" dur="1" fill="hold">
-                                          <p:stCondLst>
-                                            <p:cond delay="0"/>
-                                          </p:stCondLst>
-                                        </p:cTn>
-                                        <p:tgtEl>
-                                          <p:spTgt spid="4"/>
-                                        </p:tgtEl>
-                                        <p:attrNameLst>
-                                          <p:attrName>style.visibility</p:attrName>
-                                        </p:attrNameLst>
-                                      </p:cBhvr>
-                                      <p:to>
-                                        <p:strVal val="visible"/>
-                                      </p:to>
-                                    </p:set>
-                                  </p:childTnLst>
-                                </p:cTn>
-                              </p:par>
-                              <p:par>
-                                <p:cTn id="11" presetID="1" presetClass="entr" presetSubtype="0" fill="hold" grpId="0" nodeType="withEffect">
-                                  <p:stCondLst>
-                                    <p:cond delay="0"/>
-                                  </p:stCondLst>
-                                  <p:childTnLst>
-                                    <p:set>
-                                      <p:cBhvr>
-                                        <p:cTn id="12" dur="1" fill="hold">
-                                          <p:stCondLst>
-                                            <p:cond delay="0"/>
-                                          </p:stCondLst>
-                                        </p:cTn>
-                                        <p:tgtEl>
-                                          <p:spTgt spid="6"/>
-                                        </p:tgtEl>
-                                        <p:attrNameLst>
-                                          <p:attrName>style.visibility</p:attrName>
-                                        </p:attrNameLst>
-                                      </p:cBhvr>
-                                      <p:to>
-                                        <p:strVal val="visible"/>
-                                      </p:to>
-                                    </p:set>
-                                  </p:childTnLst>
-                                </p:cTn>
-                              </p:par>
-                            </p:childTnLst>
-                          </p:cTn>
-                        </p:par>
-                      </p:childTnLst>
-                    </p:cTn>
-                  </p:par>
-                  <p:par>
-                    <p:cTn id="13" fill="hold">
-                      <p:stCondLst>
-                        <p:cond delay="indefinite"/>
-                      </p:stCondLst>
-                      <p:childTnLst>
-                        <p:par>
-                          <p:cTn id="14" fill="hold">
-                            <p:stCondLst>
-                              <p:cond delay="0"/>
-                            </p:stCondLst>
-                            <p:childTnLst>
-                              <p:par>
-                                <p:cTn id="15" presetID="1" presetClass="entr" presetSubtype="0" fill="hold" grpId="0" nodeType="clickEffect">
-                                  <p:stCondLst>
-                                    <p:cond delay="0"/>
-                                  </p:stCondLst>
-                                  <p:childTnLst>
-                                    <p:set>
-                                      <p:cBhvr>
-                                        <p:cTn id="16" dur="1" fill="hold">
-                                          <p:stCondLst>
-                                            <p:cond delay="0"/>
-                                          </p:stCondLst>
-                                        </p:cTn>
-                                        <p:tgtEl>
-                                          <p:spTgt spid="95">
-                                            <p:txEl>
-                                              <p:pRg st="12" end="12"/>
-                                            </p:txEl>
-                                          </p:spTgt>
-                                        </p:tgtEl>
-                                        <p:attrNameLst>
-                                          <p:attrName>style.visibility</p:attrName>
-                                        </p:attrNameLst>
-                                      </p:cBhvr>
-                                      <p:to>
-                                        <p:strVal val="visible"/>
-                                      </p:to>
-                                    </p:set>
-                                  </p:childTnLst>
-                                </p:cTn>
-                              </p:par>
-                            </p:childTnLst>
-                          </p:cTn>
-                        </p:par>
-                      </p:childTnLst>
-                    </p:cTn>
-                  </p:par>
-                </p:childTnLst>
-              </p:cTn>
-              <p:prevCondLst>
-                <p:cond evt="onPrev" delay="0">
-                  <p:tgtEl>
-                    <p:sldTgt/>
-                  </p:tgtEl>
-                </p:cond>
-              </p:prevCondLst>
-              <p:nextCondLst>
-                <p:cond evt="onNext" delay="0">
-                  <p:tgtEl>
-                    <p:sldTgt/>
-                  </p:tgtEl>
-                </p:cond>
-              </p:nextCondLst>
-            </p:seq>
-          </p:childTnLst>
-        </p:cTn>
-      </p:par>
-    </p:tnLst>
-    <p:bldLst>
-      <p:bldP spid="95" grpId="0" build="p"/>
-      <p:bldP spid="6" grpId="0"/>
-    </p:bldLst>
-  </p:timing>
-</p:sld>
-</file>
-
-<file path=ppt/slides/slide20.xml><?xml version="1.0" encoding="utf-8"?>
+<file path=ppt/slides/slide19.xml><?xml version="1.0" encoding="utf-8"?>
 <p:sld xmlns:a="http://schemas.openxmlformats.org/drawingml/2006/main" xmlns:r="http://schemas.openxmlformats.org/officeDocument/2006/relationships" xmlns:p="http://schemas.openxmlformats.org/presentationml/2006/main">
   <p:cSld>
     <p:spTree>
@@ -19073,7 +17810,7 @@
           <a:lstStyle/>
           <a:p>
             <a:fld id="{DB375770-8B97-4210-92C0-B7AB3E1F40BE}" type="slidenum">
-              <a:t>20</a:t>
+              <a:t>19</a:t>
             </a:fld>
             <a:endParaRPr/>
           </a:p>
@@ -19461,7 +18198,875 @@
 </p:sld>
 </file>
 
-<file path=ppt/slides/slide21.xml><?xml version="1.0" encoding="utf-8"?>
+<file path=ppt/slides/slide2.xml><?xml version="1.0" encoding="utf-8"?>
+<p:sld xmlns:a="http://schemas.openxmlformats.org/drawingml/2006/main" xmlns:r="http://schemas.openxmlformats.org/officeDocument/2006/relationships" xmlns:p="http://schemas.openxmlformats.org/presentationml/2006/main">
+  <p:cSld>
+    <p:spTree>
+      <p:nvGrpSpPr>
+        <p:cNvPr id="1" name=""/>
+        <p:cNvGrpSpPr/>
+        <p:nvPr/>
+      </p:nvGrpSpPr>
+      <p:grpSpPr>
+        <a:xfrm>
+          <a:off x="0" y="0"/>
+          <a:ext cx="0" cy="0"/>
+          <a:chOff x="0" y="0"/>
+          <a:chExt cx="0" cy="0"/>
+        </a:xfrm>
+      </p:grpSpPr>
+      <p:sp>
+        <p:nvSpPr>
+          <p:cNvPr id="93" name="PlaceHolder 1"/>
+          <p:cNvSpPr>
+            <a:spLocks noGrp="1"/>
+          </p:cNvSpPr>
+          <p:nvPr>
+            <p:ph type="title"/>
+          </p:nvPr>
+        </p:nvSpPr>
+        <p:spPr>
+          <a:xfrm>
+            <a:off x="684000" y="584640"/>
+            <a:ext cx="5478840" cy="558000"/>
+          </a:xfrm>
+          <a:prstGeom prst="rect">
+            <a:avLst/>
+          </a:prstGeom>
+          <a:noFill/>
+          <a:ln w="0">
+            <a:noFill/>
+          </a:ln>
+        </p:spPr>
+        <p:txBody>
+          <a:bodyPr lIns="0" tIns="0" rIns="0" bIns="0" anchor="t">
+            <a:noAutofit/>
+          </a:bodyPr>
+          <a:lstStyle/>
+          <a:p>
+            <a:pPr>
+              <a:lnSpc>
+                <a:spcPct val="100000"/>
+              </a:lnSpc>
+            </a:pPr>
+            <a:r>
+              <a:rPr lang="de-DE" sz="3000" b="1" spc="-1" dirty="0">
+                <a:solidFill>
+                  <a:srgbClr val="003056"/>
+                </a:solidFill>
+                <a:latin typeface="Calibri"/>
+              </a:rPr>
+              <a:t>Most Spoken </a:t>
+            </a:r>
+            <a:r>
+              <a:rPr lang="de-DE" sz="3000" b="1" spc="-1" dirty="0" err="1">
+                <a:solidFill>
+                  <a:srgbClr val="003056"/>
+                </a:solidFill>
+                <a:latin typeface="Calibri"/>
+              </a:rPr>
+              <a:t>Languages</a:t>
+            </a:r>
+            <a:r>
+              <a:rPr lang="de-DE" sz="3000" b="1" spc="-1" dirty="0">
+                <a:solidFill>
+                  <a:srgbClr val="003056"/>
+                </a:solidFill>
+                <a:latin typeface="Calibri"/>
+              </a:rPr>
+              <a:t> (1)</a:t>
+            </a:r>
+            <a:endParaRPr lang="de-DE" sz="3000" b="0" strike="noStrike" spc="-1" dirty="0" err="1">
+              <a:solidFill>
+                <a:srgbClr val="000000"/>
+              </a:solidFill>
+              <a:latin typeface="Calibri"/>
+            </a:endParaRPr>
+          </a:p>
+        </p:txBody>
+      </p:sp>
+      <p:sp>
+        <p:nvSpPr>
+          <p:cNvPr id="94" name="PlaceHolder 2"/>
+          <p:cNvSpPr>
+            <a:spLocks noGrp="1"/>
+          </p:cNvSpPr>
+          <p:nvPr>
+            <p:ph type="ftr" idx="9"/>
+          </p:nvPr>
+        </p:nvSpPr>
+        <p:spPr>
+          <a:xfrm>
+            <a:off x="684000" y="6134400"/>
+            <a:ext cx="2895120" cy="179640"/>
+          </a:xfrm>
+          <a:prstGeom prst="rect">
+            <a:avLst/>
+          </a:prstGeom>
+          <a:noFill/>
+          <a:ln w="0">
+            <a:noFill/>
+          </a:ln>
+        </p:spPr>
+        <p:txBody>
+          <a:bodyPr lIns="0" tIns="0" rIns="0" bIns="0" anchor="t">
+            <a:noAutofit/>
+          </a:bodyPr>
+          <a:lstStyle>
+            <a:lvl1pPr>
+              <a:lnSpc>
+                <a:spcPct val="100000"/>
+              </a:lnSpc>
+              <a:buNone/>
+              <a:defRPr lang="de-DE" sz="1200" b="0" strike="noStrike" spc="-1">
+                <a:solidFill>
+                  <a:srgbClr val="003056"/>
+                </a:solidFill>
+                <a:latin typeface="Calibri"/>
+              </a:defRPr>
+            </a:lvl1pPr>
+          </a:lstStyle>
+          <a:p>
+            <a:pPr>
+              <a:lnSpc>
+                <a:spcPct val="100000"/>
+              </a:lnSpc>
+              <a:buNone/>
+            </a:pPr>
+            <a:r>
+              <a:rPr lang="de-DE" sz="1200" b="0" strike="noStrike" spc="-1" dirty="0">
+                <a:solidFill>
+                  <a:srgbClr val="003056"/>
+                </a:solidFill>
+                <a:latin typeface="Calibri"/>
+              </a:rPr>
+              <a:t>Dr. Daniel Ruffinelli - FSS 2026</a:t>
+            </a:r>
+            <a:endParaRPr lang="en-US" sz="1200" b="0" strike="noStrike" spc="-1" dirty="0">
+              <a:latin typeface="Times New Roman"/>
+            </a:endParaRPr>
+          </a:p>
+        </p:txBody>
+      </p:sp>
+      <p:sp>
+        <p:nvSpPr>
+          <p:cNvPr id="95" name="PlaceHolder 3"/>
+          <p:cNvSpPr>
+            <a:spLocks noGrp="1"/>
+          </p:cNvSpPr>
+          <p:nvPr>
+            <p:ph/>
+          </p:nvPr>
+        </p:nvSpPr>
+        <p:spPr>
+          <a:xfrm>
+            <a:off x="684000" y="1143000"/>
+            <a:ext cx="7775640" cy="4903603"/>
+          </a:xfrm>
+          <a:prstGeom prst="rect">
+            <a:avLst/>
+          </a:prstGeom>
+          <a:noFill/>
+          <a:ln w="0">
+            <a:noFill/>
+          </a:ln>
+        </p:spPr>
+        <p:txBody>
+          <a:bodyPr lIns="0" tIns="0" rIns="0" bIns="0" anchor="t">
+            <a:noAutofit/>
+          </a:bodyPr>
+          <a:lstStyle/>
+          <a:p>
+            <a:pPr marL="285750">
+              <a:lnSpc>
+                <a:spcPct val="100000"/>
+              </a:lnSpc>
+              <a:spcBef>
+                <a:spcPts val="360"/>
+              </a:spcBef>
+              <a:buClr>
+                <a:srgbClr val="003056"/>
+              </a:buClr>
+              <a:buFont typeface="Arial"/>
+              <a:buChar char="•"/>
+            </a:pPr>
+            <a:r>
+              <a:rPr lang="en-US" sz="2000" spc="-1" dirty="0">
+                <a:solidFill>
+                  <a:srgbClr val="003056"/>
+                </a:solidFill>
+                <a:latin typeface="Calibri"/>
+              </a:rPr>
+              <a:t>What are the most spoken languages in the world?</a:t>
+            </a:r>
+          </a:p>
+          <a:p>
+            <a:pPr marL="742950" lvl="1">
+              <a:lnSpc>
+                <a:spcPct val="100000"/>
+              </a:lnSpc>
+              <a:spcBef>
+                <a:spcPts val="360"/>
+              </a:spcBef>
+              <a:buClr>
+                <a:srgbClr val="003056"/>
+              </a:buClr>
+              <a:buFont typeface="Arial"/>
+              <a:buChar char="•"/>
+            </a:pPr>
+            <a:r>
+              <a:rPr lang="en-US" sz="1800" spc="-1" dirty="0">
+                <a:solidFill>
+                  <a:srgbClr val="003056"/>
+                </a:solidFill>
+                <a:latin typeface="Calibri"/>
+                <a:ea typeface="Calibri"/>
+                <a:cs typeface="Calibri"/>
+              </a:rPr>
+              <a:t>According to </a:t>
+            </a:r>
+            <a:r>
+              <a:rPr lang="en-US" sz="1800" spc="-1" dirty="0">
+                <a:solidFill>
+                  <a:srgbClr val="003056"/>
+                </a:solidFill>
+                <a:latin typeface="Calibri"/>
+                <a:ea typeface="Calibri"/>
+                <a:cs typeface="Calibri"/>
+                <a:hlinkClick r:id="rId2"/>
+              </a:rPr>
+              <a:t>Ethnologue</a:t>
+            </a:r>
+            <a:r>
+              <a:rPr lang="en-US" sz="1800" spc="-1" dirty="0">
+                <a:solidFill>
+                  <a:srgbClr val="003056"/>
+                </a:solidFill>
+                <a:latin typeface="Calibri"/>
+                <a:ea typeface="Calibri"/>
+                <a:cs typeface="Calibri"/>
+              </a:rPr>
+              <a:t>, this is the distribution for </a:t>
+            </a:r>
+            <a:r>
+              <a:rPr lang="en-US" sz="1800" i="1" spc="-1" dirty="0">
+                <a:solidFill>
+                  <a:srgbClr val="003056"/>
+                </a:solidFill>
+                <a:latin typeface="Calibri"/>
+                <a:ea typeface="Calibri"/>
+                <a:cs typeface="Calibri"/>
+              </a:rPr>
+              <a:t>native</a:t>
+            </a:r>
+            <a:r>
+              <a:rPr lang="en-US" sz="1800" spc="-1" dirty="0">
+                <a:solidFill>
+                  <a:srgbClr val="003056"/>
+                </a:solidFill>
+                <a:latin typeface="Calibri"/>
+                <a:ea typeface="Calibri"/>
+                <a:cs typeface="Calibri"/>
+              </a:rPr>
+              <a:t> speakers</a:t>
+            </a:r>
+          </a:p>
+          <a:p>
+            <a:pPr marL="742950" lvl="1">
+              <a:lnSpc>
+                <a:spcPct val="100000"/>
+              </a:lnSpc>
+              <a:spcBef>
+                <a:spcPts val="360"/>
+              </a:spcBef>
+              <a:buClr>
+                <a:srgbClr val="003056"/>
+              </a:buClr>
+              <a:buFont typeface="Arial"/>
+              <a:buChar char="•"/>
+            </a:pPr>
+            <a:endParaRPr lang="en-US" sz="1800" spc="-1" dirty="0">
+              <a:solidFill>
+                <a:srgbClr val="003056"/>
+              </a:solidFill>
+              <a:latin typeface="Calibri"/>
+              <a:ea typeface="Calibri"/>
+              <a:cs typeface="Calibri"/>
+            </a:endParaRPr>
+          </a:p>
+          <a:p>
+            <a:pPr marL="742950" lvl="1">
+              <a:lnSpc>
+                <a:spcPct val="100000"/>
+              </a:lnSpc>
+              <a:spcBef>
+                <a:spcPts val="360"/>
+              </a:spcBef>
+              <a:buClr>
+                <a:srgbClr val="003056"/>
+              </a:buClr>
+              <a:buFont typeface="Arial"/>
+              <a:buChar char="•"/>
+            </a:pPr>
+            <a:endParaRPr lang="en-US" sz="1800" spc="-1" dirty="0">
+              <a:solidFill>
+                <a:srgbClr val="003056"/>
+              </a:solidFill>
+              <a:latin typeface="Calibri"/>
+              <a:ea typeface="Calibri"/>
+              <a:cs typeface="Calibri"/>
+            </a:endParaRPr>
+          </a:p>
+          <a:p>
+            <a:pPr marL="742950" lvl="1">
+              <a:lnSpc>
+                <a:spcPct val="100000"/>
+              </a:lnSpc>
+              <a:spcBef>
+                <a:spcPts val="360"/>
+              </a:spcBef>
+              <a:buClr>
+                <a:srgbClr val="003056"/>
+              </a:buClr>
+              <a:buFont typeface="Arial"/>
+              <a:buChar char="•"/>
+            </a:pPr>
+            <a:endParaRPr lang="en-US" sz="1800" spc="-1" dirty="0">
+              <a:solidFill>
+                <a:srgbClr val="003056"/>
+              </a:solidFill>
+              <a:latin typeface="Calibri"/>
+              <a:ea typeface="Calibri"/>
+              <a:cs typeface="Calibri"/>
+            </a:endParaRPr>
+          </a:p>
+          <a:p>
+            <a:pPr marL="285750">
+              <a:lnSpc>
+                <a:spcPct val="100000"/>
+              </a:lnSpc>
+              <a:spcBef>
+                <a:spcPts val="360"/>
+              </a:spcBef>
+              <a:buClr>
+                <a:srgbClr val="003056"/>
+              </a:buClr>
+              <a:buFont typeface="Arial"/>
+              <a:buChar char="•"/>
+            </a:pPr>
+            <a:endParaRPr lang="en-US" sz="2200" spc="-1" dirty="0">
+              <a:solidFill>
+                <a:srgbClr val="003056"/>
+              </a:solidFill>
+              <a:latin typeface="Calibri"/>
+              <a:ea typeface="Calibri"/>
+              <a:cs typeface="Calibri"/>
+            </a:endParaRPr>
+          </a:p>
+          <a:p>
+            <a:pPr marL="285750">
+              <a:lnSpc>
+                <a:spcPct val="100000"/>
+              </a:lnSpc>
+              <a:spcBef>
+                <a:spcPts val="360"/>
+              </a:spcBef>
+              <a:buClr>
+                <a:srgbClr val="003056"/>
+              </a:buClr>
+              <a:buFont typeface="Arial"/>
+              <a:buChar char="•"/>
+            </a:pPr>
+            <a:endParaRPr lang="en-US" sz="2200" spc="-1" dirty="0">
+              <a:solidFill>
+                <a:srgbClr val="003056"/>
+              </a:solidFill>
+              <a:latin typeface="Calibri"/>
+              <a:ea typeface="Calibri"/>
+              <a:cs typeface="Calibri"/>
+            </a:endParaRPr>
+          </a:p>
+          <a:p>
+            <a:pPr marL="285750">
+              <a:lnSpc>
+                <a:spcPct val="100000"/>
+              </a:lnSpc>
+              <a:spcBef>
+                <a:spcPts val="360"/>
+              </a:spcBef>
+              <a:buClr>
+                <a:srgbClr val="003056"/>
+              </a:buClr>
+              <a:buFont typeface="Arial"/>
+              <a:buChar char="•"/>
+            </a:pPr>
+            <a:endParaRPr lang="en-US" sz="2200" spc="-1" dirty="0">
+              <a:solidFill>
+                <a:srgbClr val="003056"/>
+              </a:solidFill>
+              <a:latin typeface="Calibri"/>
+              <a:ea typeface="Calibri"/>
+              <a:cs typeface="Calibri"/>
+            </a:endParaRPr>
+          </a:p>
+          <a:p>
+            <a:pPr marL="285750">
+              <a:lnSpc>
+                <a:spcPct val="100000"/>
+              </a:lnSpc>
+              <a:spcBef>
+                <a:spcPts val="360"/>
+              </a:spcBef>
+              <a:buClr>
+                <a:srgbClr val="003056"/>
+              </a:buClr>
+              <a:buFont typeface="Arial"/>
+              <a:buChar char="•"/>
+            </a:pPr>
+            <a:endParaRPr lang="en-US" sz="2200" spc="-1" dirty="0">
+              <a:solidFill>
+                <a:srgbClr val="003056"/>
+              </a:solidFill>
+              <a:latin typeface="Calibri"/>
+              <a:ea typeface="Calibri"/>
+              <a:cs typeface="Calibri"/>
+            </a:endParaRPr>
+          </a:p>
+          <a:p>
+            <a:pPr marL="285750">
+              <a:lnSpc>
+                <a:spcPct val="100000"/>
+              </a:lnSpc>
+              <a:spcBef>
+                <a:spcPts val="360"/>
+              </a:spcBef>
+              <a:buClr>
+                <a:srgbClr val="003056"/>
+              </a:buClr>
+              <a:buFont typeface="Arial"/>
+              <a:buChar char="•"/>
+            </a:pPr>
+            <a:endParaRPr lang="en-US" sz="2200" spc="-1" dirty="0">
+              <a:solidFill>
+                <a:srgbClr val="003056"/>
+              </a:solidFill>
+              <a:latin typeface="Calibri"/>
+              <a:ea typeface="Calibri"/>
+              <a:cs typeface="Calibri"/>
+            </a:endParaRPr>
+          </a:p>
+          <a:p>
+            <a:pPr marL="285750">
+              <a:lnSpc>
+                <a:spcPct val="100000"/>
+              </a:lnSpc>
+              <a:spcBef>
+                <a:spcPts val="360"/>
+              </a:spcBef>
+              <a:buClr>
+                <a:srgbClr val="003056"/>
+              </a:buClr>
+              <a:buFont typeface="Arial"/>
+              <a:buChar char="•"/>
+            </a:pPr>
+            <a:endParaRPr lang="en-US" sz="2200" spc="-1" dirty="0">
+              <a:solidFill>
+                <a:srgbClr val="003056"/>
+              </a:solidFill>
+              <a:latin typeface="Calibri"/>
+              <a:ea typeface="Calibri"/>
+              <a:cs typeface="Calibri"/>
+            </a:endParaRPr>
+          </a:p>
+          <a:p>
+            <a:pPr marL="285750">
+              <a:lnSpc>
+                <a:spcPct val="100000"/>
+              </a:lnSpc>
+              <a:spcBef>
+                <a:spcPts val="360"/>
+              </a:spcBef>
+              <a:buClr>
+                <a:srgbClr val="003056"/>
+              </a:buClr>
+              <a:buFont typeface="Arial"/>
+              <a:buChar char="•"/>
+            </a:pPr>
+            <a:endParaRPr lang="en-US" sz="2200" spc="-1" dirty="0">
+              <a:solidFill>
+                <a:srgbClr val="003056"/>
+              </a:solidFill>
+              <a:latin typeface="Calibri"/>
+              <a:ea typeface="Calibri"/>
+              <a:cs typeface="Calibri"/>
+            </a:endParaRPr>
+          </a:p>
+          <a:p>
+            <a:pPr marL="285750">
+              <a:lnSpc>
+                <a:spcPct val="100000"/>
+              </a:lnSpc>
+              <a:spcBef>
+                <a:spcPts val="360"/>
+              </a:spcBef>
+              <a:buClr>
+                <a:srgbClr val="003056"/>
+              </a:buClr>
+              <a:buFont typeface="Arial"/>
+              <a:buChar char="•"/>
+            </a:pPr>
+            <a:r>
+              <a:rPr lang="en-US" sz="2000" spc="-1" dirty="0">
+                <a:solidFill>
+                  <a:srgbClr val="003056"/>
+                </a:solidFill>
+                <a:latin typeface="Calibri"/>
+                <a:ea typeface="Calibri"/>
+                <a:cs typeface="Calibri"/>
+              </a:rPr>
+              <a:t>The top 10 languages cover 3 billion people (37.5% of the world)</a:t>
+            </a:r>
+            <a:endParaRPr lang="en-US" sz="2200" spc="-1" dirty="0">
+              <a:solidFill>
+                <a:srgbClr val="003056"/>
+              </a:solidFill>
+              <a:latin typeface="Calibri"/>
+              <a:ea typeface="Calibri"/>
+              <a:cs typeface="Calibri"/>
+            </a:endParaRPr>
+          </a:p>
+        </p:txBody>
+      </p:sp>
+      <p:sp>
+        <p:nvSpPr>
+          <p:cNvPr id="5" name="PlaceHolder 4"/>
+          <p:cNvSpPr>
+            <a:spLocks noGrp="1"/>
+          </p:cNvSpPr>
+          <p:nvPr>
+            <p:ph type="sldNum" idx="6"/>
+          </p:nvPr>
+        </p:nvSpPr>
+        <p:spPr/>
+        <p:txBody>
+          <a:bodyPr/>
+          <a:lstStyle/>
+          <a:p>
+            <a:fld id="{AC7497A8-7E1F-45D3-91D1-10848132C468}" type="slidenum">
+              <a:t>2</a:t>
+            </a:fld>
+            <a:endParaRPr/>
+          </a:p>
+        </p:txBody>
+      </p:sp>
+      <p:pic>
+        <p:nvPicPr>
+          <p:cNvPr id="4" name="Picture 3" descr="A screenshot of a screen shot&#10;&#10;Description automatically generated">
+            <a:extLst>
+              <a:ext uri="{FF2B5EF4-FFF2-40B4-BE49-F238E27FC236}">
+                <a16:creationId xmlns:a16="http://schemas.microsoft.com/office/drawing/2014/main" id="{3E4BF857-653A-30ED-374C-BA3E3DCAB4A8}"/>
+              </a:ext>
+            </a:extLst>
+          </p:cNvPr>
+          <p:cNvPicPr>
+            <a:picLocks noChangeAspect="1"/>
+          </p:cNvPicPr>
+          <p:nvPr/>
+        </p:nvPicPr>
+        <p:blipFill>
+          <a:blip r:embed="rId3"/>
+          <a:stretch>
+            <a:fillRect/>
+          </a:stretch>
+        </p:blipFill>
+        <p:spPr>
+          <a:xfrm>
+            <a:off x="1479734" y="1871206"/>
+            <a:ext cx="6194016" cy="3447578"/>
+          </a:xfrm>
+          <a:prstGeom prst="rect">
+            <a:avLst/>
+          </a:prstGeom>
+        </p:spPr>
+      </p:pic>
+      <p:sp>
+        <p:nvSpPr>
+          <p:cNvPr id="6" name="TextBox 5">
+            <a:extLst>
+              <a:ext uri="{FF2B5EF4-FFF2-40B4-BE49-F238E27FC236}">
+                <a16:creationId xmlns:a16="http://schemas.microsoft.com/office/drawing/2014/main" id="{823C1546-E861-58AB-52F9-BB33BE414C31}"/>
+              </a:ext>
+            </a:extLst>
+          </p:cNvPr>
+          <p:cNvSpPr txBox="1"/>
+          <p:nvPr/>
+        </p:nvSpPr>
+        <p:spPr>
+          <a:xfrm>
+            <a:off x="7673750" y="5017817"/>
+            <a:ext cx="1176199" cy="307777"/>
+          </a:xfrm>
+          <a:prstGeom prst="rect">
+            <a:avLst/>
+          </a:prstGeom>
+          <a:noFill/>
+        </p:spPr>
+        <p:txBody>
+          <a:bodyPr rot="0" spcFirstLastPara="0" vertOverflow="overflow" horzOverflow="overflow" vert="horz" wrap="square" lIns="91440" tIns="45720" rIns="91440" bIns="45720" numCol="1" spcCol="0" rtlCol="0" fromWordArt="0" anchor="t" anchorCtr="0" forceAA="0" compatLnSpc="1">
+            <a:prstTxWarp prst="textNoShape">
+              <a:avLst/>
+            </a:prstTxWarp>
+            <a:spAutoFit/>
+          </a:bodyPr>
+          <a:lstStyle/>
+          <a:p>
+            <a:r>
+              <a:rPr lang="en-US" sz="1400" dirty="0">
+                <a:latin typeface="Calibri"/>
+                <a:hlinkClick r:id="rId4"/>
+              </a:rPr>
+              <a:t>Image source</a:t>
+            </a:r>
+            <a:endParaRPr lang="en-US" sz="1400" dirty="0">
+              <a:latin typeface="Calibri"/>
+            </a:endParaRPr>
+          </a:p>
+        </p:txBody>
+      </p:sp>
+    </p:spTree>
+    <p:extLst>
+      <p:ext uri="{BB962C8B-B14F-4D97-AF65-F5344CB8AC3E}">
+        <p14:creationId xmlns:p14="http://schemas.microsoft.com/office/powerpoint/2010/main" val="654399792"/>
+      </p:ext>
+    </p:extLst>
+  </p:cSld>
+  <p:clrMapOvr>
+    <a:masterClrMapping/>
+  </p:clrMapOvr>
+  <p:transition>
+    <p:fade/>
+  </p:transition>
+  <p:timing>
+    <p:tnLst>
+      <p:par>
+        <p:cTn id="1" dur="indefinite" restart="never" nodeType="tmRoot">
+          <p:childTnLst>
+            <p:seq concurrent="1" nextAc="seek">
+              <p:cTn id="2" dur="indefinite" nodeType="mainSeq">
+                <p:childTnLst>
+                  <p:par>
+                    <p:cTn id="3" fill="hold">
+                      <p:stCondLst>
+                        <p:cond delay="indefinite"/>
+                      </p:stCondLst>
+                      <p:childTnLst>
+                        <p:par>
+                          <p:cTn id="4" fill="hold">
+                            <p:stCondLst>
+                              <p:cond delay="0"/>
+                            </p:stCondLst>
+                            <p:childTnLst>
+                              <p:par>
+                                <p:cTn id="5" presetID="1" presetClass="entr" presetSubtype="0" fill="hold" grpId="0" nodeType="clickEffect">
+                                  <p:stCondLst>
+                                    <p:cond delay="0"/>
+                                  </p:stCondLst>
+                                  <p:childTnLst>
+                                    <p:set>
+                                      <p:cBhvr>
+                                        <p:cTn id="6" dur="1" fill="hold">
+                                          <p:stCondLst>
+                                            <p:cond delay="0"/>
+                                          </p:stCondLst>
+                                        </p:cTn>
+                                        <p:tgtEl>
+                                          <p:spTgt spid="95">
+                                            <p:txEl>
+                                              <p:pRg st="0" end="0"/>
+                                            </p:txEl>
+                                          </p:spTgt>
+                                        </p:tgtEl>
+                                        <p:attrNameLst>
+                                          <p:attrName>style.visibility</p:attrName>
+                                        </p:attrNameLst>
+                                      </p:cBhvr>
+                                      <p:to>
+                                        <p:strVal val="visible"/>
+                                      </p:to>
+                                    </p:set>
+                                  </p:childTnLst>
+                                </p:cTn>
+                              </p:par>
+                              <p:par>
+                                <p:cTn id="7" presetID="1" presetClass="entr" presetSubtype="0" fill="hold" grpId="0" nodeType="withEffect">
+                                  <p:stCondLst>
+                                    <p:cond delay="0"/>
+                                  </p:stCondLst>
+                                  <p:childTnLst>
+                                    <p:set>
+                                      <p:cBhvr>
+                                        <p:cTn id="8" dur="1" fill="hold">
+                                          <p:stCondLst>
+                                            <p:cond delay="0"/>
+                                          </p:stCondLst>
+                                        </p:cTn>
+                                        <p:tgtEl>
+                                          <p:spTgt spid="95">
+                                            <p:txEl>
+                                              <p:pRg st="1" end="1"/>
+                                            </p:txEl>
+                                          </p:spTgt>
+                                        </p:tgtEl>
+                                        <p:attrNameLst>
+                                          <p:attrName>style.visibility</p:attrName>
+                                        </p:attrNameLst>
+                                      </p:cBhvr>
+                                      <p:to>
+                                        <p:strVal val="visible"/>
+                                      </p:to>
+                                    </p:set>
+                                  </p:childTnLst>
+                                </p:cTn>
+                              </p:par>
+                              <p:par>
+                                <p:cTn id="9" presetID="1" presetClass="entr" presetSubtype="0" fill="hold" nodeType="withEffect">
+                                  <p:stCondLst>
+                                    <p:cond delay="0"/>
+                                  </p:stCondLst>
+                                  <p:childTnLst>
+                                    <p:set>
+                                      <p:cBhvr>
+                                        <p:cTn id="10" dur="1" fill="hold">
+                                          <p:stCondLst>
+                                            <p:cond delay="0"/>
+                                          </p:stCondLst>
+                                        </p:cTn>
+                                        <p:tgtEl>
+                                          <p:spTgt spid="4"/>
+                                        </p:tgtEl>
+                                        <p:attrNameLst>
+                                          <p:attrName>style.visibility</p:attrName>
+                                        </p:attrNameLst>
+                                      </p:cBhvr>
+                                      <p:to>
+                                        <p:strVal val="visible"/>
+                                      </p:to>
+                                    </p:set>
+                                  </p:childTnLst>
+                                </p:cTn>
+                              </p:par>
+                              <p:par>
+                                <p:cTn id="11" presetID="1" presetClass="entr" presetSubtype="0" fill="hold" grpId="0" nodeType="withEffect">
+                                  <p:stCondLst>
+                                    <p:cond delay="0"/>
+                                  </p:stCondLst>
+                                  <p:childTnLst>
+                                    <p:set>
+                                      <p:cBhvr>
+                                        <p:cTn id="12" dur="1" fill="hold">
+                                          <p:stCondLst>
+                                            <p:cond delay="0"/>
+                                          </p:stCondLst>
+                                        </p:cTn>
+                                        <p:tgtEl>
+                                          <p:spTgt spid="6"/>
+                                        </p:tgtEl>
+                                        <p:attrNameLst>
+                                          <p:attrName>style.visibility</p:attrName>
+                                        </p:attrNameLst>
+                                      </p:cBhvr>
+                                      <p:to>
+                                        <p:strVal val="visible"/>
+                                      </p:to>
+                                    </p:set>
+                                  </p:childTnLst>
+                                </p:cTn>
+                              </p:par>
+                            </p:childTnLst>
+                          </p:cTn>
+                        </p:par>
+                      </p:childTnLst>
+                    </p:cTn>
+                  </p:par>
+                  <p:par>
+                    <p:cTn id="13" fill="hold">
+                      <p:stCondLst>
+                        <p:cond delay="indefinite"/>
+                      </p:stCondLst>
+                      <p:childTnLst>
+                        <p:par>
+                          <p:cTn id="14" fill="hold">
+                            <p:stCondLst>
+                              <p:cond delay="0"/>
+                            </p:stCondLst>
+                            <p:childTnLst>
+                              <p:par>
+                                <p:cTn id="15" presetID="1" presetClass="entr" presetSubtype="0" fill="hold" grpId="0" nodeType="clickEffect">
+                                  <p:stCondLst>
+                                    <p:cond delay="0"/>
+                                  </p:stCondLst>
+                                  <p:childTnLst>
+                                    <p:set>
+                                      <p:cBhvr>
+                                        <p:cTn id="16" dur="1" fill="hold">
+                                          <p:stCondLst>
+                                            <p:cond delay="0"/>
+                                          </p:stCondLst>
+                                        </p:cTn>
+                                        <p:tgtEl>
+                                          <p:spTgt spid="95">
+                                            <p:txEl>
+                                              <p:pRg st="12" end="12"/>
+                                            </p:txEl>
+                                          </p:spTgt>
+                                        </p:tgtEl>
+                                        <p:attrNameLst>
+                                          <p:attrName>style.visibility</p:attrName>
+                                        </p:attrNameLst>
+                                      </p:cBhvr>
+                                      <p:to>
+                                        <p:strVal val="visible"/>
+                                      </p:to>
+                                    </p:set>
+                                  </p:childTnLst>
+                                </p:cTn>
+                              </p:par>
+                            </p:childTnLst>
+                          </p:cTn>
+                        </p:par>
+                      </p:childTnLst>
+                    </p:cTn>
+                  </p:par>
+                </p:childTnLst>
+              </p:cTn>
+              <p:prevCondLst>
+                <p:cond evt="onPrev" delay="0">
+                  <p:tgtEl>
+                    <p:sldTgt/>
+                  </p:tgtEl>
+                </p:cond>
+              </p:prevCondLst>
+              <p:nextCondLst>
+                <p:cond evt="onNext" delay="0">
+                  <p:tgtEl>
+                    <p:sldTgt/>
+                  </p:tgtEl>
+                </p:cond>
+              </p:nextCondLst>
+            </p:seq>
+          </p:childTnLst>
+        </p:cTn>
+      </p:par>
+    </p:tnLst>
+    <p:bldLst>
+      <p:bldP spid="95" grpId="0" build="p"/>
+      <p:bldP spid="6" grpId="0"/>
+    </p:bldLst>
+  </p:timing>
+</p:sld>
+</file>
+
+<file path=ppt/slides/slide20.xml><?xml version="1.0" encoding="utf-8"?>
 <p:sld xmlns:a="http://schemas.openxmlformats.org/drawingml/2006/main" xmlns:r="http://schemas.openxmlformats.org/officeDocument/2006/relationships" xmlns:p="http://schemas.openxmlformats.org/presentationml/2006/main">
   <p:cSld>
     <p:spTree>
@@ -19754,7 +19359,7 @@
           <a:lstStyle/>
           <a:p>
             <a:fld id="{5F2B43E7-B823-4A23-841C-33749B8E44AD}" type="slidenum">
-              <a:t>21</a:t>
+              <a:t>20</a:t>
             </a:fld>
             <a:endParaRPr/>
           </a:p>
@@ -19776,7 +19381,7 @@
 </p:sld>
 </file>
 
-<file path=ppt/slides/slide22.xml><?xml version="1.0" encoding="utf-8"?>
+<file path=ppt/slides/slide21.xml><?xml version="1.0" encoding="utf-8"?>
 <p:sld xmlns:a="http://schemas.openxmlformats.org/drawingml/2006/main" xmlns:r="http://schemas.openxmlformats.org/officeDocument/2006/relationships" xmlns:p="http://schemas.openxmlformats.org/presentationml/2006/main">
   <p:cSld>
     <p:spTree>
@@ -20389,7 +19994,7 @@
           <a:lstStyle/>
           <a:p>
             <a:fld id="{DB375770-8B97-4210-92C0-B7AB3E1F40BE}" type="slidenum">
-              <a:t>22</a:t>
+              <a:t>21</a:t>
             </a:fld>
             <a:endParaRPr/>
           </a:p>
@@ -20839,7 +20444,7 @@
 </p:sld>
 </file>
 
-<file path=ppt/slides/slide23.xml><?xml version="1.0" encoding="utf-8"?>
+<file path=ppt/slides/slide22.xml><?xml version="1.0" encoding="utf-8"?>
 <p:sld xmlns:a="http://schemas.openxmlformats.org/drawingml/2006/main" xmlns:r="http://schemas.openxmlformats.org/officeDocument/2006/relationships" xmlns:p="http://schemas.openxmlformats.org/presentationml/2006/main">
   <p:cSld>
     <p:spTree>
@@ -21522,7 +21127,7 @@
           <a:lstStyle/>
           <a:p>
             <a:fld id="{DB375770-8B97-4210-92C0-B7AB3E1F40BE}" type="slidenum">
-              <a:t>23</a:t>
+              <a:t>22</a:t>
             </a:fld>
             <a:endParaRPr/>
           </a:p>
@@ -22083,7 +21688,7 @@
 </p:sld>
 </file>
 
-<file path=ppt/slides/slide24.xml><?xml version="1.0" encoding="utf-8"?>
+<file path=ppt/slides/slide23.xml><?xml version="1.0" encoding="utf-8"?>
 <p:sld xmlns:a="http://schemas.openxmlformats.org/drawingml/2006/main" xmlns:r="http://schemas.openxmlformats.org/officeDocument/2006/relationships" xmlns:p="http://schemas.openxmlformats.org/presentationml/2006/main">
   <p:cSld>
     <p:spTree>
@@ -22708,7 +22313,7 @@
           <a:lstStyle/>
           <a:p>
             <a:fld id="{DB375770-8B97-4210-92C0-B7AB3E1F40BE}" type="slidenum">
-              <a:t>24</a:t>
+              <a:t>23</a:t>
             </a:fld>
             <a:endParaRPr/>
           </a:p>
@@ -23189,7 +22794,7 @@
 </p:sld>
 </file>
 
-<file path=ppt/slides/slide25.xml><?xml version="1.0" encoding="utf-8"?>
+<file path=ppt/slides/slide24.xml><?xml version="1.0" encoding="utf-8"?>
 <p:sld xmlns:a="http://schemas.openxmlformats.org/drawingml/2006/main" xmlns:r="http://schemas.openxmlformats.org/officeDocument/2006/relationships" xmlns:p="http://schemas.openxmlformats.org/presentationml/2006/main">
   <p:cSld>
     <p:spTree>
@@ -23827,7 +23432,7 @@
           <a:lstStyle/>
           <a:p>
             <a:fld id="{DB375770-8B97-4210-92C0-B7AB3E1F40BE}" type="slidenum">
-              <a:t>25</a:t>
+              <a:t>24</a:t>
             </a:fld>
             <a:endParaRPr/>
           </a:p>
@@ -24215,7 +23820,7 @@
 </p:sld>
 </file>
 
-<file path=ppt/slides/slide26.xml><?xml version="1.0" encoding="utf-8"?>
+<file path=ppt/slides/slide25.xml><?xml version="1.0" encoding="utf-8"?>
 <p:sld xmlns:a="http://schemas.openxmlformats.org/drawingml/2006/main" xmlns:r="http://schemas.openxmlformats.org/officeDocument/2006/relationships" xmlns:p="http://schemas.openxmlformats.org/presentationml/2006/main">
   <p:cSld>
     <p:spTree>
@@ -24929,7 +24534,7 @@
           <a:lstStyle/>
           <a:p>
             <a:fld id="{DB375770-8B97-4210-92C0-B7AB3E1F40BE}" type="slidenum">
-              <a:t>26</a:t>
+              <a:t>25</a:t>
             </a:fld>
             <a:endParaRPr/>
           </a:p>
@@ -25379,7 +24984,7 @@
 </p:sld>
 </file>
 
-<file path=ppt/slides/slide27.xml><?xml version="1.0" encoding="utf-8"?>
+<file path=ppt/slides/slide26.xml><?xml version="1.0" encoding="utf-8"?>
 <p:sld xmlns:a="http://schemas.openxmlformats.org/drawingml/2006/main" xmlns:r="http://schemas.openxmlformats.org/officeDocument/2006/relationships" xmlns:p="http://schemas.openxmlformats.org/presentationml/2006/main">
   <p:cSld>
     <p:spTree>
@@ -25897,7 +25502,7 @@
           <a:lstStyle/>
           <a:p>
             <a:fld id="{DB375770-8B97-4210-92C0-B7AB3E1F40BE}" type="slidenum">
-              <a:t>27</a:t>
+              <a:t>26</a:t>
             </a:fld>
             <a:endParaRPr/>
           </a:p>
@@ -26231,7 +25836,7 @@
 </p:sld>
 </file>
 
-<file path=ppt/slides/slide28.xml><?xml version="1.0" encoding="utf-8"?>
+<file path=ppt/slides/slide27.xml><?xml version="1.0" encoding="utf-8"?>
 <p:sld xmlns:a="http://schemas.openxmlformats.org/drawingml/2006/main" xmlns:r="http://schemas.openxmlformats.org/officeDocument/2006/relationships" xmlns:p="http://schemas.openxmlformats.org/presentationml/2006/main">
   <p:cSld>
     <p:spTree>
@@ -26850,7 +26455,7 @@
           <a:lstStyle/>
           <a:p>
             <a:fld id="{DB375770-8B97-4210-92C0-B7AB3E1F40BE}" type="slidenum">
-              <a:t>28</a:t>
+              <a:t>27</a:t>
             </a:fld>
             <a:endParaRPr/>
           </a:p>
@@ -27331,7 +26936,7 @@
 </p:sld>
 </file>
 
-<file path=ppt/slides/slide29.xml><?xml version="1.0" encoding="utf-8"?>
+<file path=ppt/slides/slide28.xml><?xml version="1.0" encoding="utf-8"?>
 <p:sld xmlns:a="http://schemas.openxmlformats.org/drawingml/2006/main" xmlns:r="http://schemas.openxmlformats.org/officeDocument/2006/relationships" xmlns:p="http://schemas.openxmlformats.org/presentationml/2006/main">
   <p:cSld>
     <p:spTree>
@@ -28095,7 +27700,7 @@
           <a:lstStyle/>
           <a:p>
             <a:fld id="{DB375770-8B97-4210-92C0-B7AB3E1F40BE}" type="slidenum">
-              <a:t>29</a:t>
+              <a:t>28</a:t>
             </a:fld>
             <a:endParaRPr/>
           </a:p>
@@ -28625,879 +28230,7 @@
 </p:sld>
 </file>
 
-<file path=ppt/slides/slide3.xml><?xml version="1.0" encoding="utf-8"?>
-<p:sld xmlns:a="http://schemas.openxmlformats.org/drawingml/2006/main" xmlns:r="http://schemas.openxmlformats.org/officeDocument/2006/relationships" xmlns:p="http://schemas.openxmlformats.org/presentationml/2006/main">
-  <p:cSld>
-    <p:spTree>
-      <p:nvGrpSpPr>
-        <p:cNvPr id="1" name=""/>
-        <p:cNvGrpSpPr/>
-        <p:nvPr/>
-      </p:nvGrpSpPr>
-      <p:grpSpPr>
-        <a:xfrm>
-          <a:off x="0" y="0"/>
-          <a:ext cx="0" cy="0"/>
-          <a:chOff x="0" y="0"/>
-          <a:chExt cx="0" cy="0"/>
-        </a:xfrm>
-      </p:grpSpPr>
-      <p:sp>
-        <p:nvSpPr>
-          <p:cNvPr id="93" name="PlaceHolder 1"/>
-          <p:cNvSpPr>
-            <a:spLocks noGrp="1"/>
-          </p:cNvSpPr>
-          <p:nvPr>
-            <p:ph type="title"/>
-          </p:nvPr>
-        </p:nvSpPr>
-        <p:spPr>
-          <a:xfrm>
-            <a:off x="684000" y="584640"/>
-            <a:ext cx="5478840" cy="558000"/>
-          </a:xfrm>
-          <a:prstGeom prst="rect">
-            <a:avLst/>
-          </a:prstGeom>
-          <a:noFill/>
-          <a:ln w="0">
-            <a:noFill/>
-          </a:ln>
-        </p:spPr>
-        <p:txBody>
-          <a:bodyPr lIns="0" tIns="0" rIns="0" bIns="0" anchor="t">
-            <a:noAutofit/>
-          </a:bodyPr>
-          <a:lstStyle/>
-          <a:p>
-            <a:pPr>
-              <a:lnSpc>
-                <a:spcPct val="100000"/>
-              </a:lnSpc>
-            </a:pPr>
-            <a:r>
-              <a:rPr lang="de-DE" sz="3000" b="1" spc="-1" dirty="0">
-                <a:solidFill>
-                  <a:srgbClr val="003056"/>
-                </a:solidFill>
-                <a:latin typeface="Calibri"/>
-              </a:rPr>
-              <a:t>Most Spoken </a:t>
-            </a:r>
-            <a:r>
-              <a:rPr lang="de-DE" sz="3000" b="1" spc="-1" dirty="0" err="1">
-                <a:solidFill>
-                  <a:srgbClr val="003056"/>
-                </a:solidFill>
-                <a:latin typeface="Calibri"/>
-              </a:rPr>
-              <a:t>Languages</a:t>
-            </a:r>
-            <a:r>
-              <a:rPr lang="de-DE" sz="3000" b="1" spc="-1" dirty="0">
-                <a:solidFill>
-                  <a:srgbClr val="003056"/>
-                </a:solidFill>
-                <a:latin typeface="Calibri"/>
-              </a:rPr>
-              <a:t> (2)</a:t>
-            </a:r>
-            <a:endParaRPr lang="de-DE" sz="3000" b="0" strike="noStrike" spc="-1" dirty="0" err="1">
-              <a:solidFill>
-                <a:srgbClr val="000000"/>
-              </a:solidFill>
-              <a:latin typeface="Calibri"/>
-            </a:endParaRPr>
-          </a:p>
-        </p:txBody>
-      </p:sp>
-      <p:sp>
-        <p:nvSpPr>
-          <p:cNvPr id="94" name="PlaceHolder 2"/>
-          <p:cNvSpPr>
-            <a:spLocks noGrp="1"/>
-          </p:cNvSpPr>
-          <p:nvPr>
-            <p:ph type="ftr" idx="9"/>
-          </p:nvPr>
-        </p:nvSpPr>
-        <p:spPr>
-          <a:xfrm>
-            <a:off x="684000" y="6134400"/>
-            <a:ext cx="2895120" cy="179640"/>
-          </a:xfrm>
-          <a:prstGeom prst="rect">
-            <a:avLst/>
-          </a:prstGeom>
-          <a:noFill/>
-          <a:ln w="0">
-            <a:noFill/>
-          </a:ln>
-        </p:spPr>
-        <p:txBody>
-          <a:bodyPr lIns="0" tIns="0" rIns="0" bIns="0" anchor="t">
-            <a:noAutofit/>
-          </a:bodyPr>
-          <a:lstStyle>
-            <a:lvl1pPr>
-              <a:lnSpc>
-                <a:spcPct val="100000"/>
-              </a:lnSpc>
-              <a:buNone/>
-              <a:defRPr lang="de-DE" sz="1200" b="0" strike="noStrike" spc="-1">
-                <a:solidFill>
-                  <a:srgbClr val="003056"/>
-                </a:solidFill>
-                <a:latin typeface="Calibri"/>
-              </a:defRPr>
-            </a:lvl1pPr>
-          </a:lstStyle>
-          <a:p>
-            <a:pPr>
-              <a:lnSpc>
-                <a:spcPct val="100000"/>
-              </a:lnSpc>
-              <a:buNone/>
-            </a:pPr>
-            <a:r>
-              <a:rPr lang="de-DE" sz="1200" b="0" strike="noStrike" spc="-1" dirty="0">
-                <a:solidFill>
-                  <a:srgbClr val="003056"/>
-                </a:solidFill>
-                <a:latin typeface="Calibri"/>
-              </a:rPr>
-              <a:t>Dr. Daniel Ruffinelli - FSS 2026</a:t>
-            </a:r>
-            <a:endParaRPr lang="en-US" sz="1200" b="0" strike="noStrike" spc="-1" dirty="0">
-              <a:latin typeface="Times New Roman"/>
-            </a:endParaRPr>
-          </a:p>
-        </p:txBody>
-      </p:sp>
-      <p:sp>
-        <p:nvSpPr>
-          <p:cNvPr id="95" name="PlaceHolder 3"/>
-          <p:cNvSpPr>
-            <a:spLocks noGrp="1"/>
-          </p:cNvSpPr>
-          <p:nvPr>
-            <p:ph/>
-          </p:nvPr>
-        </p:nvSpPr>
-        <p:spPr>
-          <a:xfrm>
-            <a:off x="684000" y="1143000"/>
-            <a:ext cx="7775640" cy="4903603"/>
-          </a:xfrm>
-          <a:prstGeom prst="rect">
-            <a:avLst/>
-          </a:prstGeom>
-          <a:noFill/>
-          <a:ln w="0">
-            <a:noFill/>
-          </a:ln>
-        </p:spPr>
-        <p:txBody>
-          <a:bodyPr lIns="0" tIns="0" rIns="0" bIns="0" anchor="t">
-            <a:noAutofit/>
-          </a:bodyPr>
-          <a:lstStyle/>
-          <a:p>
-            <a:pPr marL="285750">
-              <a:lnSpc>
-                <a:spcPct val="100000"/>
-              </a:lnSpc>
-              <a:spcBef>
-                <a:spcPts val="360"/>
-              </a:spcBef>
-              <a:buClr>
-                <a:srgbClr val="003056"/>
-              </a:buClr>
-              <a:buFont typeface="Arial"/>
-              <a:buChar char="•"/>
-            </a:pPr>
-            <a:r>
-              <a:rPr lang="en-US" sz="2000" spc="-1" dirty="0">
-                <a:solidFill>
-                  <a:srgbClr val="003056"/>
-                </a:solidFill>
-                <a:latin typeface="Calibri"/>
-              </a:rPr>
-              <a:t>What if we break this into </a:t>
-            </a:r>
-            <a:r>
-              <a:rPr lang="en-US" sz="2000" i="1" spc="-1" dirty="0">
-                <a:solidFill>
-                  <a:srgbClr val="003056"/>
-                </a:solidFill>
-                <a:latin typeface="Calibri"/>
-              </a:rPr>
-              <a:t>native vs non-native</a:t>
-            </a:r>
-            <a:r>
-              <a:rPr lang="en-US" sz="2000" spc="-1" dirty="0">
-                <a:solidFill>
-                  <a:srgbClr val="003056"/>
-                </a:solidFill>
-                <a:latin typeface="Calibri"/>
-              </a:rPr>
-              <a:t> speakers?</a:t>
-            </a:r>
-          </a:p>
-          <a:p>
-            <a:pPr marL="742950" lvl="1">
-              <a:lnSpc>
-                <a:spcPct val="100000"/>
-              </a:lnSpc>
-              <a:spcBef>
-                <a:spcPts val="360"/>
-              </a:spcBef>
-              <a:buClr>
-                <a:srgbClr val="003056"/>
-              </a:buClr>
-              <a:buFont typeface="Arial"/>
-              <a:buChar char="•"/>
-            </a:pPr>
-            <a:r>
-              <a:rPr lang="en-US" sz="1800" spc="-1" dirty="0">
-                <a:solidFill>
-                  <a:srgbClr val="003056"/>
-                </a:solidFill>
-                <a:latin typeface="Calibri"/>
-                <a:ea typeface="Calibri"/>
-                <a:cs typeface="Calibri"/>
-              </a:rPr>
-              <a:t>Again, according to </a:t>
-            </a:r>
-            <a:r>
-              <a:rPr lang="en-US" sz="1800" spc="-1" dirty="0">
-                <a:solidFill>
-                  <a:srgbClr val="003056"/>
-                </a:solidFill>
-                <a:latin typeface="Calibri"/>
-                <a:ea typeface="Calibri"/>
-                <a:cs typeface="Calibri"/>
-                <a:hlinkClick r:id="rId2"/>
-              </a:rPr>
-              <a:t>Ethnologue</a:t>
-            </a:r>
-            <a:r>
-              <a:rPr lang="en-US" sz="1800" spc="-1" dirty="0">
-                <a:solidFill>
-                  <a:srgbClr val="003056"/>
-                </a:solidFill>
-                <a:latin typeface="Calibri"/>
-                <a:ea typeface="Calibri"/>
-                <a:cs typeface="Calibri"/>
-              </a:rPr>
-              <a:t>... </a:t>
-            </a:r>
-            <a:endParaRPr lang="en-US" sz="1800" spc="-1" dirty="0">
-              <a:solidFill>
-                <a:srgbClr val="003056"/>
-              </a:solidFill>
-              <a:latin typeface="DejaVu Sans"/>
-              <a:ea typeface="Calibri"/>
-              <a:cs typeface="Calibri"/>
-            </a:endParaRPr>
-          </a:p>
-          <a:p>
-            <a:pPr marL="742950" lvl="1">
-              <a:lnSpc>
-                <a:spcPct val="100000"/>
-              </a:lnSpc>
-              <a:spcBef>
-                <a:spcPts val="360"/>
-              </a:spcBef>
-              <a:buClr>
-                <a:srgbClr val="003056"/>
-              </a:buClr>
-              <a:buFont typeface="Arial"/>
-              <a:buChar char="•"/>
-            </a:pPr>
-            <a:endParaRPr lang="en-US" sz="1800" spc="-1" dirty="0">
-              <a:solidFill>
-                <a:srgbClr val="003056"/>
-              </a:solidFill>
-              <a:latin typeface="Calibri"/>
-              <a:ea typeface="Calibri"/>
-              <a:cs typeface="Calibri"/>
-            </a:endParaRPr>
-          </a:p>
-          <a:p>
-            <a:pPr marL="285750">
-              <a:lnSpc>
-                <a:spcPct val="100000"/>
-              </a:lnSpc>
-              <a:spcBef>
-                <a:spcPts val="360"/>
-              </a:spcBef>
-              <a:buClr>
-                <a:srgbClr val="003056"/>
-              </a:buClr>
-              <a:buFont typeface="Arial"/>
-              <a:buChar char="•"/>
-            </a:pPr>
-            <a:endParaRPr lang="en-US" sz="2200" spc="-1" dirty="0">
-              <a:solidFill>
-                <a:srgbClr val="003056"/>
-              </a:solidFill>
-              <a:latin typeface="Calibri"/>
-              <a:ea typeface="Calibri"/>
-              <a:cs typeface="Calibri"/>
-            </a:endParaRPr>
-          </a:p>
-          <a:p>
-            <a:pPr marL="285750">
-              <a:lnSpc>
-                <a:spcPct val="100000"/>
-              </a:lnSpc>
-              <a:spcBef>
-                <a:spcPts val="360"/>
-              </a:spcBef>
-              <a:buClr>
-                <a:srgbClr val="003056"/>
-              </a:buClr>
-              <a:buFont typeface="Arial"/>
-              <a:buChar char="•"/>
-            </a:pPr>
-            <a:endParaRPr lang="en-US" sz="2200" spc="-1" dirty="0">
-              <a:solidFill>
-                <a:srgbClr val="003056"/>
-              </a:solidFill>
-              <a:latin typeface="Calibri"/>
-              <a:ea typeface="Calibri"/>
-              <a:cs typeface="Calibri"/>
-            </a:endParaRPr>
-          </a:p>
-          <a:p>
-            <a:pPr marL="285750">
-              <a:lnSpc>
-                <a:spcPct val="100000"/>
-              </a:lnSpc>
-              <a:spcBef>
-                <a:spcPts val="360"/>
-              </a:spcBef>
-              <a:buClr>
-                <a:srgbClr val="003056"/>
-              </a:buClr>
-              <a:buFont typeface="Arial"/>
-              <a:buChar char="•"/>
-            </a:pPr>
-            <a:endParaRPr lang="en-US" sz="2200" spc="-1" dirty="0">
-              <a:solidFill>
-                <a:srgbClr val="003056"/>
-              </a:solidFill>
-              <a:latin typeface="Calibri"/>
-              <a:ea typeface="Calibri"/>
-              <a:cs typeface="Calibri"/>
-            </a:endParaRPr>
-          </a:p>
-          <a:p>
-            <a:pPr marL="285750">
-              <a:lnSpc>
-                <a:spcPct val="100000"/>
-              </a:lnSpc>
-              <a:spcBef>
-                <a:spcPts val="360"/>
-              </a:spcBef>
-              <a:buClr>
-                <a:srgbClr val="003056"/>
-              </a:buClr>
-              <a:buFont typeface="Arial"/>
-              <a:buChar char="•"/>
-            </a:pPr>
-            <a:endParaRPr lang="en-US" sz="2200" spc="-1" dirty="0">
-              <a:solidFill>
-                <a:srgbClr val="003056"/>
-              </a:solidFill>
-              <a:latin typeface="Calibri"/>
-              <a:ea typeface="Calibri"/>
-              <a:cs typeface="Calibri"/>
-            </a:endParaRPr>
-          </a:p>
-          <a:p>
-            <a:pPr marL="285750">
-              <a:lnSpc>
-                <a:spcPct val="100000"/>
-              </a:lnSpc>
-              <a:spcBef>
-                <a:spcPts val="360"/>
-              </a:spcBef>
-              <a:buClr>
-                <a:srgbClr val="003056"/>
-              </a:buClr>
-              <a:buFont typeface="Arial"/>
-              <a:buChar char="•"/>
-            </a:pPr>
-            <a:endParaRPr lang="en-US" sz="2200" spc="-1" dirty="0">
-              <a:solidFill>
-                <a:srgbClr val="003056"/>
-              </a:solidFill>
-              <a:latin typeface="Calibri"/>
-              <a:ea typeface="Calibri"/>
-              <a:cs typeface="Calibri"/>
-            </a:endParaRPr>
-          </a:p>
-          <a:p>
-            <a:pPr marL="285750">
-              <a:lnSpc>
-                <a:spcPct val="100000"/>
-              </a:lnSpc>
-              <a:spcBef>
-                <a:spcPts val="360"/>
-              </a:spcBef>
-              <a:buClr>
-                <a:srgbClr val="003056"/>
-              </a:buClr>
-              <a:buFont typeface="Arial"/>
-              <a:buChar char="•"/>
-            </a:pPr>
-            <a:endParaRPr lang="en-US" sz="2200" spc="-1" dirty="0">
-              <a:solidFill>
-                <a:srgbClr val="003056"/>
-              </a:solidFill>
-              <a:latin typeface="Calibri"/>
-              <a:ea typeface="Calibri"/>
-              <a:cs typeface="Calibri"/>
-            </a:endParaRPr>
-          </a:p>
-          <a:p>
-            <a:pPr marL="285750">
-              <a:lnSpc>
-                <a:spcPct val="100000"/>
-              </a:lnSpc>
-              <a:spcBef>
-                <a:spcPts val="360"/>
-              </a:spcBef>
-              <a:buClr>
-                <a:srgbClr val="003056"/>
-              </a:buClr>
-              <a:buFont typeface="Arial"/>
-              <a:buChar char="•"/>
-            </a:pPr>
-            <a:endParaRPr lang="en-US" sz="2200" spc="-1" dirty="0">
-              <a:solidFill>
-                <a:srgbClr val="003056"/>
-              </a:solidFill>
-              <a:latin typeface="Calibri"/>
-              <a:ea typeface="Calibri"/>
-              <a:cs typeface="Calibri"/>
-            </a:endParaRPr>
-          </a:p>
-          <a:p>
-            <a:pPr marL="285750">
-              <a:lnSpc>
-                <a:spcPct val="100000"/>
-              </a:lnSpc>
-              <a:spcBef>
-                <a:spcPts val="360"/>
-              </a:spcBef>
-              <a:buClr>
-                <a:srgbClr val="003056"/>
-              </a:buClr>
-              <a:buFont typeface="Arial"/>
-              <a:buChar char="•"/>
-            </a:pPr>
-            <a:endParaRPr lang="en-US" sz="2200" spc="-1" dirty="0">
-              <a:solidFill>
-                <a:srgbClr val="003056"/>
-              </a:solidFill>
-              <a:latin typeface="Calibri"/>
-              <a:ea typeface="Calibri"/>
-              <a:cs typeface="Calibri"/>
-            </a:endParaRPr>
-          </a:p>
-          <a:p>
-            <a:pPr marL="285750">
-              <a:lnSpc>
-                <a:spcPct val="100000"/>
-              </a:lnSpc>
-              <a:spcBef>
-                <a:spcPts val="360"/>
-              </a:spcBef>
-              <a:buClr>
-                <a:srgbClr val="003056"/>
-              </a:buClr>
-              <a:buFont typeface="Arial"/>
-              <a:buChar char="•"/>
-            </a:pPr>
-            <a:endParaRPr lang="en-US" sz="2200" spc="-1" dirty="0">
-              <a:solidFill>
-                <a:srgbClr val="003056"/>
-              </a:solidFill>
-              <a:latin typeface="Calibri"/>
-              <a:ea typeface="Calibri"/>
-              <a:cs typeface="Calibri"/>
-            </a:endParaRPr>
-          </a:p>
-          <a:p>
-            <a:pPr marL="285750">
-              <a:lnSpc>
-                <a:spcPct val="100000"/>
-              </a:lnSpc>
-              <a:spcBef>
-                <a:spcPts val="360"/>
-              </a:spcBef>
-              <a:buClr>
-                <a:srgbClr val="003056"/>
-              </a:buClr>
-              <a:buFont typeface="Arial"/>
-              <a:buChar char="•"/>
-            </a:pPr>
-            <a:r>
-              <a:rPr lang="en-US" sz="2000" spc="-1" dirty="0">
-                <a:solidFill>
-                  <a:srgbClr val="003056"/>
-                </a:solidFill>
-                <a:latin typeface="Calibri"/>
-                <a:ea typeface="Calibri"/>
-                <a:cs typeface="Calibri"/>
-              </a:rPr>
-              <a:t>The top 5 languages cover 4 billion people (50% of the world)</a:t>
-            </a:r>
-            <a:endParaRPr lang="en-US" sz="2200" spc="-1" dirty="0">
-              <a:solidFill>
-                <a:srgbClr val="003056"/>
-              </a:solidFill>
-              <a:latin typeface="Calibri"/>
-              <a:ea typeface="Calibri"/>
-              <a:cs typeface="Calibri"/>
-            </a:endParaRPr>
-          </a:p>
-        </p:txBody>
-      </p:sp>
-      <p:sp>
-        <p:nvSpPr>
-          <p:cNvPr id="5" name="PlaceHolder 4"/>
-          <p:cNvSpPr>
-            <a:spLocks noGrp="1"/>
-          </p:cNvSpPr>
-          <p:nvPr>
-            <p:ph type="sldNum" idx="6"/>
-          </p:nvPr>
-        </p:nvSpPr>
-        <p:spPr/>
-        <p:txBody>
-          <a:bodyPr/>
-          <a:lstStyle/>
-          <a:p>
-            <a:fld id="{AC7497A8-7E1F-45D3-91D1-10848132C468}" type="slidenum">
-              <a:t>3</a:t>
-            </a:fld>
-            <a:endParaRPr/>
-          </a:p>
-        </p:txBody>
-      </p:sp>
-      <p:pic>
-        <p:nvPicPr>
-          <p:cNvPr id="2" name="Picture 1" descr="A screenshot of a computer screen&#10;&#10;Description automatically generated">
-            <a:extLst>
-              <a:ext uri="{FF2B5EF4-FFF2-40B4-BE49-F238E27FC236}">
-                <a16:creationId xmlns:a16="http://schemas.microsoft.com/office/drawing/2014/main" id="{17FAD69A-2516-B2AC-D1CA-E71171629C79}"/>
-              </a:ext>
-            </a:extLst>
-          </p:cNvPr>
-          <p:cNvPicPr>
-            <a:picLocks noChangeAspect="1"/>
-          </p:cNvPicPr>
-          <p:nvPr/>
-        </p:nvPicPr>
-        <p:blipFill>
-          <a:blip r:embed="rId3"/>
-          <a:stretch>
-            <a:fillRect/>
-          </a:stretch>
-        </p:blipFill>
-        <p:spPr>
-          <a:xfrm>
-            <a:off x="512216" y="1909464"/>
-            <a:ext cx="8119567" cy="3380546"/>
-          </a:xfrm>
-          <a:prstGeom prst="rect">
-            <a:avLst/>
-          </a:prstGeom>
-        </p:spPr>
-      </p:pic>
-      <p:sp>
-        <p:nvSpPr>
-          <p:cNvPr id="3" name="TextBox 2">
-            <a:extLst>
-              <a:ext uri="{FF2B5EF4-FFF2-40B4-BE49-F238E27FC236}">
-                <a16:creationId xmlns:a16="http://schemas.microsoft.com/office/drawing/2014/main" id="{092ED94E-BAA0-A65E-DFC2-3F6F03434191}"/>
-              </a:ext>
-            </a:extLst>
-          </p:cNvPr>
-          <p:cNvSpPr txBox="1"/>
-          <p:nvPr/>
-        </p:nvSpPr>
-        <p:spPr>
-          <a:xfrm>
-            <a:off x="7465071" y="5292896"/>
-            <a:ext cx="1166714" cy="307777"/>
-          </a:xfrm>
-          <a:prstGeom prst="rect">
-            <a:avLst/>
-          </a:prstGeom>
-          <a:noFill/>
-        </p:spPr>
-        <p:txBody>
-          <a:bodyPr rot="0" spcFirstLastPara="0" vertOverflow="overflow" horzOverflow="overflow" vert="horz" wrap="square" lIns="91440" tIns="45720" rIns="91440" bIns="45720" numCol="1" spcCol="0" rtlCol="0" fromWordArt="0" anchor="t" anchorCtr="0" forceAA="0" compatLnSpc="1">
-            <a:prstTxWarp prst="textNoShape">
-              <a:avLst/>
-            </a:prstTxWarp>
-            <a:spAutoFit/>
-          </a:bodyPr>
-          <a:lstStyle/>
-          <a:p>
-            <a:r>
-              <a:rPr lang="en-US" sz="1400" dirty="0">
-                <a:latin typeface="Calibri"/>
-                <a:hlinkClick r:id="rId4"/>
-              </a:rPr>
-              <a:t>Image source</a:t>
-            </a:r>
-            <a:endParaRPr lang="en-US" sz="1400" dirty="0">
-              <a:latin typeface="Calibri"/>
-            </a:endParaRPr>
-          </a:p>
-        </p:txBody>
-      </p:sp>
-    </p:spTree>
-    <p:extLst>
-      <p:ext uri="{BB962C8B-B14F-4D97-AF65-F5344CB8AC3E}">
-        <p14:creationId xmlns:p14="http://schemas.microsoft.com/office/powerpoint/2010/main" val="3549647095"/>
-      </p:ext>
-    </p:extLst>
-  </p:cSld>
-  <p:clrMapOvr>
-    <a:masterClrMapping/>
-  </p:clrMapOvr>
-  <p:transition>
-    <p:fade/>
-  </p:transition>
-  <p:timing>
-    <p:tnLst>
-      <p:par>
-        <p:cTn id="1" dur="indefinite" restart="never" nodeType="tmRoot">
-          <p:childTnLst>
-            <p:seq concurrent="1" nextAc="seek">
-              <p:cTn id="2" dur="indefinite" nodeType="mainSeq">
-                <p:childTnLst>
-                  <p:par>
-                    <p:cTn id="3" fill="hold">
-                      <p:stCondLst>
-                        <p:cond delay="indefinite"/>
-                      </p:stCondLst>
-                      <p:childTnLst>
-                        <p:par>
-                          <p:cTn id="4" fill="hold">
-                            <p:stCondLst>
-                              <p:cond delay="0"/>
-                            </p:stCondLst>
-                            <p:childTnLst>
-                              <p:par>
-                                <p:cTn id="5" presetID="1" presetClass="entr" presetSubtype="0" fill="hold" grpId="0" nodeType="clickEffect">
-                                  <p:stCondLst>
-                                    <p:cond delay="0"/>
-                                  </p:stCondLst>
-                                  <p:childTnLst>
-                                    <p:set>
-                                      <p:cBhvr>
-                                        <p:cTn id="6" dur="1" fill="hold">
-                                          <p:stCondLst>
-                                            <p:cond delay="0"/>
-                                          </p:stCondLst>
-                                        </p:cTn>
-                                        <p:tgtEl>
-                                          <p:spTgt spid="95">
-                                            <p:txEl>
-                                              <p:pRg st="0" end="0"/>
-                                            </p:txEl>
-                                          </p:spTgt>
-                                        </p:tgtEl>
-                                        <p:attrNameLst>
-                                          <p:attrName>style.visibility</p:attrName>
-                                        </p:attrNameLst>
-                                      </p:cBhvr>
-                                      <p:to>
-                                        <p:strVal val="visible"/>
-                                      </p:to>
-                                    </p:set>
-                                  </p:childTnLst>
-                                </p:cTn>
-                              </p:par>
-                              <p:par>
-                                <p:cTn id="7" presetID="1" presetClass="entr" presetSubtype="0" fill="hold" grpId="0" nodeType="withEffect">
-                                  <p:stCondLst>
-                                    <p:cond delay="0"/>
-                                  </p:stCondLst>
-                                  <p:childTnLst>
-                                    <p:set>
-                                      <p:cBhvr>
-                                        <p:cTn id="8" dur="1" fill="hold">
-                                          <p:stCondLst>
-                                            <p:cond delay="0"/>
-                                          </p:stCondLst>
-                                        </p:cTn>
-                                        <p:tgtEl>
-                                          <p:spTgt spid="95">
-                                            <p:txEl>
-                                              <p:pRg st="1" end="1"/>
-                                            </p:txEl>
-                                          </p:spTgt>
-                                        </p:tgtEl>
-                                        <p:attrNameLst>
-                                          <p:attrName>style.visibility</p:attrName>
-                                        </p:attrNameLst>
-                                      </p:cBhvr>
-                                      <p:to>
-                                        <p:strVal val="visible"/>
-                                      </p:to>
-                                    </p:set>
-                                  </p:childTnLst>
-                                </p:cTn>
-                              </p:par>
-                              <p:par>
-                                <p:cTn id="9" presetID="1" presetClass="entr" presetSubtype="0" fill="hold" nodeType="withEffect">
-                                  <p:stCondLst>
-                                    <p:cond delay="0"/>
-                                  </p:stCondLst>
-                                  <p:childTnLst>
-                                    <p:set>
-                                      <p:cBhvr>
-                                        <p:cTn id="10" dur="1" fill="hold">
-                                          <p:stCondLst>
-                                            <p:cond delay="0"/>
-                                          </p:stCondLst>
-                                        </p:cTn>
-                                        <p:tgtEl>
-                                          <p:spTgt spid="2"/>
-                                        </p:tgtEl>
-                                        <p:attrNameLst>
-                                          <p:attrName>style.visibility</p:attrName>
-                                        </p:attrNameLst>
-                                      </p:cBhvr>
-                                      <p:to>
-                                        <p:strVal val="visible"/>
-                                      </p:to>
-                                    </p:set>
-                                  </p:childTnLst>
-                                </p:cTn>
-                              </p:par>
-                              <p:par>
-                                <p:cTn id="11" presetID="1" presetClass="entr" presetSubtype="0" fill="hold" grpId="0" nodeType="withEffect">
-                                  <p:stCondLst>
-                                    <p:cond delay="0"/>
-                                  </p:stCondLst>
-                                  <p:childTnLst>
-                                    <p:set>
-                                      <p:cBhvr>
-                                        <p:cTn id="12" dur="1" fill="hold">
-                                          <p:stCondLst>
-                                            <p:cond delay="0"/>
-                                          </p:stCondLst>
-                                        </p:cTn>
-                                        <p:tgtEl>
-                                          <p:spTgt spid="3"/>
-                                        </p:tgtEl>
-                                        <p:attrNameLst>
-                                          <p:attrName>style.visibility</p:attrName>
-                                        </p:attrNameLst>
-                                      </p:cBhvr>
-                                      <p:to>
-                                        <p:strVal val="visible"/>
-                                      </p:to>
-                                    </p:set>
-                                  </p:childTnLst>
-                                </p:cTn>
-                              </p:par>
-                            </p:childTnLst>
-                          </p:cTn>
-                        </p:par>
-                      </p:childTnLst>
-                    </p:cTn>
-                  </p:par>
-                  <p:par>
-                    <p:cTn id="13" fill="hold">
-                      <p:stCondLst>
-                        <p:cond delay="indefinite"/>
-                      </p:stCondLst>
-                      <p:childTnLst>
-                        <p:par>
-                          <p:cTn id="14" fill="hold">
-                            <p:stCondLst>
-                              <p:cond delay="0"/>
-                            </p:stCondLst>
-                            <p:childTnLst>
-                              <p:par>
-                                <p:cTn id="15" presetID="1" presetClass="entr" presetSubtype="0" fill="hold" grpId="0" nodeType="clickEffect">
-                                  <p:stCondLst>
-                                    <p:cond delay="0"/>
-                                  </p:stCondLst>
-                                  <p:childTnLst>
-                                    <p:set>
-                                      <p:cBhvr>
-                                        <p:cTn id="16" dur="1" fill="hold">
-                                          <p:stCondLst>
-                                            <p:cond delay="0"/>
-                                          </p:stCondLst>
-                                        </p:cTn>
-                                        <p:tgtEl>
-                                          <p:spTgt spid="95">
-                                            <p:txEl>
-                                              <p:pRg st="12" end="12"/>
-                                            </p:txEl>
-                                          </p:spTgt>
-                                        </p:tgtEl>
-                                        <p:attrNameLst>
-                                          <p:attrName>style.visibility</p:attrName>
-                                        </p:attrNameLst>
-                                      </p:cBhvr>
-                                      <p:to>
-                                        <p:strVal val="visible"/>
-                                      </p:to>
-                                    </p:set>
-                                  </p:childTnLst>
-                                </p:cTn>
-                              </p:par>
-                            </p:childTnLst>
-                          </p:cTn>
-                        </p:par>
-                      </p:childTnLst>
-                    </p:cTn>
-                  </p:par>
-                </p:childTnLst>
-              </p:cTn>
-              <p:prevCondLst>
-                <p:cond evt="onPrev" delay="0">
-                  <p:tgtEl>
-                    <p:sldTgt/>
-                  </p:tgtEl>
-                </p:cond>
-              </p:prevCondLst>
-              <p:nextCondLst>
-                <p:cond evt="onNext" delay="0">
-                  <p:tgtEl>
-                    <p:sldTgt/>
-                  </p:tgtEl>
-                </p:cond>
-              </p:nextCondLst>
-            </p:seq>
-          </p:childTnLst>
-        </p:cTn>
-      </p:par>
-    </p:tnLst>
-    <p:bldLst>
-      <p:bldP spid="95" grpId="0" build="p"/>
-      <p:bldP spid="3" grpId="0"/>
-    </p:bldLst>
-  </p:timing>
-</p:sld>
-</file>
-
-<file path=ppt/slides/slide30.xml><?xml version="1.0" encoding="utf-8"?>
+<file path=ppt/slides/slide29.xml><?xml version="1.0" encoding="utf-8"?>
 <p:sld xmlns:a="http://schemas.openxmlformats.org/drawingml/2006/main" xmlns:r="http://schemas.openxmlformats.org/officeDocument/2006/relationships" xmlns:p="http://schemas.openxmlformats.org/presentationml/2006/main">
   <p:cSld>
     <p:spTree>
@@ -30120,7 +28853,7 @@
           <a:lstStyle/>
           <a:p>
             <a:fld id="{DB375770-8B97-4210-92C0-B7AB3E1F40BE}" type="slidenum">
-              <a:t>30</a:t>
+              <a:t>29</a:t>
             </a:fld>
             <a:endParaRPr/>
           </a:p>
@@ -30557,7 +29290,879 @@
 </p:sld>
 </file>
 
-<file path=ppt/slides/slide31.xml><?xml version="1.0" encoding="utf-8"?>
+<file path=ppt/slides/slide3.xml><?xml version="1.0" encoding="utf-8"?>
+<p:sld xmlns:a="http://schemas.openxmlformats.org/drawingml/2006/main" xmlns:r="http://schemas.openxmlformats.org/officeDocument/2006/relationships" xmlns:p="http://schemas.openxmlformats.org/presentationml/2006/main">
+  <p:cSld>
+    <p:spTree>
+      <p:nvGrpSpPr>
+        <p:cNvPr id="1" name=""/>
+        <p:cNvGrpSpPr/>
+        <p:nvPr/>
+      </p:nvGrpSpPr>
+      <p:grpSpPr>
+        <a:xfrm>
+          <a:off x="0" y="0"/>
+          <a:ext cx="0" cy="0"/>
+          <a:chOff x="0" y="0"/>
+          <a:chExt cx="0" cy="0"/>
+        </a:xfrm>
+      </p:grpSpPr>
+      <p:sp>
+        <p:nvSpPr>
+          <p:cNvPr id="93" name="PlaceHolder 1"/>
+          <p:cNvSpPr>
+            <a:spLocks noGrp="1"/>
+          </p:cNvSpPr>
+          <p:nvPr>
+            <p:ph type="title"/>
+          </p:nvPr>
+        </p:nvSpPr>
+        <p:spPr>
+          <a:xfrm>
+            <a:off x="684000" y="584640"/>
+            <a:ext cx="5478840" cy="558000"/>
+          </a:xfrm>
+          <a:prstGeom prst="rect">
+            <a:avLst/>
+          </a:prstGeom>
+          <a:noFill/>
+          <a:ln w="0">
+            <a:noFill/>
+          </a:ln>
+        </p:spPr>
+        <p:txBody>
+          <a:bodyPr lIns="0" tIns="0" rIns="0" bIns="0" anchor="t">
+            <a:noAutofit/>
+          </a:bodyPr>
+          <a:lstStyle/>
+          <a:p>
+            <a:pPr>
+              <a:lnSpc>
+                <a:spcPct val="100000"/>
+              </a:lnSpc>
+            </a:pPr>
+            <a:r>
+              <a:rPr lang="de-DE" sz="3000" b="1" spc="-1" dirty="0">
+                <a:solidFill>
+                  <a:srgbClr val="003056"/>
+                </a:solidFill>
+                <a:latin typeface="Calibri"/>
+              </a:rPr>
+              <a:t>Most Spoken </a:t>
+            </a:r>
+            <a:r>
+              <a:rPr lang="de-DE" sz="3000" b="1" spc="-1" dirty="0" err="1">
+                <a:solidFill>
+                  <a:srgbClr val="003056"/>
+                </a:solidFill>
+                <a:latin typeface="Calibri"/>
+              </a:rPr>
+              <a:t>Languages</a:t>
+            </a:r>
+            <a:r>
+              <a:rPr lang="de-DE" sz="3000" b="1" spc="-1" dirty="0">
+                <a:solidFill>
+                  <a:srgbClr val="003056"/>
+                </a:solidFill>
+                <a:latin typeface="Calibri"/>
+              </a:rPr>
+              <a:t> (2)</a:t>
+            </a:r>
+            <a:endParaRPr lang="de-DE" sz="3000" b="0" strike="noStrike" spc="-1" dirty="0" err="1">
+              <a:solidFill>
+                <a:srgbClr val="000000"/>
+              </a:solidFill>
+              <a:latin typeface="Calibri"/>
+            </a:endParaRPr>
+          </a:p>
+        </p:txBody>
+      </p:sp>
+      <p:sp>
+        <p:nvSpPr>
+          <p:cNvPr id="94" name="PlaceHolder 2"/>
+          <p:cNvSpPr>
+            <a:spLocks noGrp="1"/>
+          </p:cNvSpPr>
+          <p:nvPr>
+            <p:ph type="ftr" idx="9"/>
+          </p:nvPr>
+        </p:nvSpPr>
+        <p:spPr>
+          <a:xfrm>
+            <a:off x="684000" y="6134400"/>
+            <a:ext cx="2895120" cy="179640"/>
+          </a:xfrm>
+          <a:prstGeom prst="rect">
+            <a:avLst/>
+          </a:prstGeom>
+          <a:noFill/>
+          <a:ln w="0">
+            <a:noFill/>
+          </a:ln>
+        </p:spPr>
+        <p:txBody>
+          <a:bodyPr lIns="0" tIns="0" rIns="0" bIns="0" anchor="t">
+            <a:noAutofit/>
+          </a:bodyPr>
+          <a:lstStyle>
+            <a:lvl1pPr>
+              <a:lnSpc>
+                <a:spcPct val="100000"/>
+              </a:lnSpc>
+              <a:buNone/>
+              <a:defRPr lang="de-DE" sz="1200" b="0" strike="noStrike" spc="-1">
+                <a:solidFill>
+                  <a:srgbClr val="003056"/>
+                </a:solidFill>
+                <a:latin typeface="Calibri"/>
+              </a:defRPr>
+            </a:lvl1pPr>
+          </a:lstStyle>
+          <a:p>
+            <a:pPr>
+              <a:lnSpc>
+                <a:spcPct val="100000"/>
+              </a:lnSpc>
+              <a:buNone/>
+            </a:pPr>
+            <a:r>
+              <a:rPr lang="de-DE" sz="1200" b="0" strike="noStrike" spc="-1" dirty="0">
+                <a:solidFill>
+                  <a:srgbClr val="003056"/>
+                </a:solidFill>
+                <a:latin typeface="Calibri"/>
+              </a:rPr>
+              <a:t>Dr. Daniel Ruffinelli - FSS 2026</a:t>
+            </a:r>
+            <a:endParaRPr lang="en-US" sz="1200" b="0" strike="noStrike" spc="-1" dirty="0">
+              <a:latin typeface="Times New Roman"/>
+            </a:endParaRPr>
+          </a:p>
+        </p:txBody>
+      </p:sp>
+      <p:sp>
+        <p:nvSpPr>
+          <p:cNvPr id="95" name="PlaceHolder 3"/>
+          <p:cNvSpPr>
+            <a:spLocks noGrp="1"/>
+          </p:cNvSpPr>
+          <p:nvPr>
+            <p:ph/>
+          </p:nvPr>
+        </p:nvSpPr>
+        <p:spPr>
+          <a:xfrm>
+            <a:off x="684000" y="1143000"/>
+            <a:ext cx="7775640" cy="4903603"/>
+          </a:xfrm>
+          <a:prstGeom prst="rect">
+            <a:avLst/>
+          </a:prstGeom>
+          <a:noFill/>
+          <a:ln w="0">
+            <a:noFill/>
+          </a:ln>
+        </p:spPr>
+        <p:txBody>
+          <a:bodyPr lIns="0" tIns="0" rIns="0" bIns="0" anchor="t">
+            <a:noAutofit/>
+          </a:bodyPr>
+          <a:lstStyle/>
+          <a:p>
+            <a:pPr marL="285750">
+              <a:lnSpc>
+                <a:spcPct val="100000"/>
+              </a:lnSpc>
+              <a:spcBef>
+                <a:spcPts val="360"/>
+              </a:spcBef>
+              <a:buClr>
+                <a:srgbClr val="003056"/>
+              </a:buClr>
+              <a:buFont typeface="Arial"/>
+              <a:buChar char="•"/>
+            </a:pPr>
+            <a:r>
+              <a:rPr lang="en-US" sz="2000" spc="-1" dirty="0">
+                <a:solidFill>
+                  <a:srgbClr val="003056"/>
+                </a:solidFill>
+                <a:latin typeface="Calibri"/>
+              </a:rPr>
+              <a:t>What if we break this into </a:t>
+            </a:r>
+            <a:r>
+              <a:rPr lang="en-US" sz="2000" i="1" spc="-1" dirty="0">
+                <a:solidFill>
+                  <a:srgbClr val="003056"/>
+                </a:solidFill>
+                <a:latin typeface="Calibri"/>
+              </a:rPr>
+              <a:t>native vs non-native</a:t>
+            </a:r>
+            <a:r>
+              <a:rPr lang="en-US" sz="2000" spc="-1" dirty="0">
+                <a:solidFill>
+                  <a:srgbClr val="003056"/>
+                </a:solidFill>
+                <a:latin typeface="Calibri"/>
+              </a:rPr>
+              <a:t> speakers?</a:t>
+            </a:r>
+          </a:p>
+          <a:p>
+            <a:pPr marL="742950" lvl="1">
+              <a:lnSpc>
+                <a:spcPct val="100000"/>
+              </a:lnSpc>
+              <a:spcBef>
+                <a:spcPts val="360"/>
+              </a:spcBef>
+              <a:buClr>
+                <a:srgbClr val="003056"/>
+              </a:buClr>
+              <a:buFont typeface="Arial"/>
+              <a:buChar char="•"/>
+            </a:pPr>
+            <a:r>
+              <a:rPr lang="en-US" sz="1800" spc="-1" dirty="0">
+                <a:solidFill>
+                  <a:srgbClr val="003056"/>
+                </a:solidFill>
+                <a:latin typeface="Calibri"/>
+                <a:ea typeface="Calibri"/>
+                <a:cs typeface="Calibri"/>
+              </a:rPr>
+              <a:t>Again, according to </a:t>
+            </a:r>
+            <a:r>
+              <a:rPr lang="en-US" sz="1800" spc="-1" dirty="0">
+                <a:solidFill>
+                  <a:srgbClr val="003056"/>
+                </a:solidFill>
+                <a:latin typeface="Calibri"/>
+                <a:ea typeface="Calibri"/>
+                <a:cs typeface="Calibri"/>
+                <a:hlinkClick r:id="rId2"/>
+              </a:rPr>
+              <a:t>Ethnologue</a:t>
+            </a:r>
+            <a:r>
+              <a:rPr lang="en-US" sz="1800" spc="-1" dirty="0">
+                <a:solidFill>
+                  <a:srgbClr val="003056"/>
+                </a:solidFill>
+                <a:latin typeface="Calibri"/>
+                <a:ea typeface="Calibri"/>
+                <a:cs typeface="Calibri"/>
+              </a:rPr>
+              <a:t>... </a:t>
+            </a:r>
+            <a:endParaRPr lang="en-US" sz="1800" spc="-1" dirty="0">
+              <a:solidFill>
+                <a:srgbClr val="003056"/>
+              </a:solidFill>
+              <a:latin typeface="DejaVu Sans"/>
+              <a:ea typeface="Calibri"/>
+              <a:cs typeface="Calibri"/>
+            </a:endParaRPr>
+          </a:p>
+          <a:p>
+            <a:pPr marL="742950" lvl="1">
+              <a:lnSpc>
+                <a:spcPct val="100000"/>
+              </a:lnSpc>
+              <a:spcBef>
+                <a:spcPts val="360"/>
+              </a:spcBef>
+              <a:buClr>
+                <a:srgbClr val="003056"/>
+              </a:buClr>
+              <a:buFont typeface="Arial"/>
+              <a:buChar char="•"/>
+            </a:pPr>
+            <a:endParaRPr lang="en-US" sz="1800" spc="-1" dirty="0">
+              <a:solidFill>
+                <a:srgbClr val="003056"/>
+              </a:solidFill>
+              <a:latin typeface="Calibri"/>
+              <a:ea typeface="Calibri"/>
+              <a:cs typeface="Calibri"/>
+            </a:endParaRPr>
+          </a:p>
+          <a:p>
+            <a:pPr marL="285750">
+              <a:lnSpc>
+                <a:spcPct val="100000"/>
+              </a:lnSpc>
+              <a:spcBef>
+                <a:spcPts val="360"/>
+              </a:spcBef>
+              <a:buClr>
+                <a:srgbClr val="003056"/>
+              </a:buClr>
+              <a:buFont typeface="Arial"/>
+              <a:buChar char="•"/>
+            </a:pPr>
+            <a:endParaRPr lang="en-US" sz="2200" spc="-1" dirty="0">
+              <a:solidFill>
+                <a:srgbClr val="003056"/>
+              </a:solidFill>
+              <a:latin typeface="Calibri"/>
+              <a:ea typeface="Calibri"/>
+              <a:cs typeface="Calibri"/>
+            </a:endParaRPr>
+          </a:p>
+          <a:p>
+            <a:pPr marL="285750">
+              <a:lnSpc>
+                <a:spcPct val="100000"/>
+              </a:lnSpc>
+              <a:spcBef>
+                <a:spcPts val="360"/>
+              </a:spcBef>
+              <a:buClr>
+                <a:srgbClr val="003056"/>
+              </a:buClr>
+              <a:buFont typeface="Arial"/>
+              <a:buChar char="•"/>
+            </a:pPr>
+            <a:endParaRPr lang="en-US" sz="2200" spc="-1" dirty="0">
+              <a:solidFill>
+                <a:srgbClr val="003056"/>
+              </a:solidFill>
+              <a:latin typeface="Calibri"/>
+              <a:ea typeface="Calibri"/>
+              <a:cs typeface="Calibri"/>
+            </a:endParaRPr>
+          </a:p>
+          <a:p>
+            <a:pPr marL="285750">
+              <a:lnSpc>
+                <a:spcPct val="100000"/>
+              </a:lnSpc>
+              <a:spcBef>
+                <a:spcPts val="360"/>
+              </a:spcBef>
+              <a:buClr>
+                <a:srgbClr val="003056"/>
+              </a:buClr>
+              <a:buFont typeface="Arial"/>
+              <a:buChar char="•"/>
+            </a:pPr>
+            <a:endParaRPr lang="en-US" sz="2200" spc="-1" dirty="0">
+              <a:solidFill>
+                <a:srgbClr val="003056"/>
+              </a:solidFill>
+              <a:latin typeface="Calibri"/>
+              <a:ea typeface="Calibri"/>
+              <a:cs typeface="Calibri"/>
+            </a:endParaRPr>
+          </a:p>
+          <a:p>
+            <a:pPr marL="285750">
+              <a:lnSpc>
+                <a:spcPct val="100000"/>
+              </a:lnSpc>
+              <a:spcBef>
+                <a:spcPts val="360"/>
+              </a:spcBef>
+              <a:buClr>
+                <a:srgbClr val="003056"/>
+              </a:buClr>
+              <a:buFont typeface="Arial"/>
+              <a:buChar char="•"/>
+            </a:pPr>
+            <a:endParaRPr lang="en-US" sz="2200" spc="-1" dirty="0">
+              <a:solidFill>
+                <a:srgbClr val="003056"/>
+              </a:solidFill>
+              <a:latin typeface="Calibri"/>
+              <a:ea typeface="Calibri"/>
+              <a:cs typeface="Calibri"/>
+            </a:endParaRPr>
+          </a:p>
+          <a:p>
+            <a:pPr marL="285750">
+              <a:lnSpc>
+                <a:spcPct val="100000"/>
+              </a:lnSpc>
+              <a:spcBef>
+                <a:spcPts val="360"/>
+              </a:spcBef>
+              <a:buClr>
+                <a:srgbClr val="003056"/>
+              </a:buClr>
+              <a:buFont typeface="Arial"/>
+              <a:buChar char="•"/>
+            </a:pPr>
+            <a:endParaRPr lang="en-US" sz="2200" spc="-1" dirty="0">
+              <a:solidFill>
+                <a:srgbClr val="003056"/>
+              </a:solidFill>
+              <a:latin typeface="Calibri"/>
+              <a:ea typeface="Calibri"/>
+              <a:cs typeface="Calibri"/>
+            </a:endParaRPr>
+          </a:p>
+          <a:p>
+            <a:pPr marL="285750">
+              <a:lnSpc>
+                <a:spcPct val="100000"/>
+              </a:lnSpc>
+              <a:spcBef>
+                <a:spcPts val="360"/>
+              </a:spcBef>
+              <a:buClr>
+                <a:srgbClr val="003056"/>
+              </a:buClr>
+              <a:buFont typeface="Arial"/>
+              <a:buChar char="•"/>
+            </a:pPr>
+            <a:endParaRPr lang="en-US" sz="2200" spc="-1" dirty="0">
+              <a:solidFill>
+                <a:srgbClr val="003056"/>
+              </a:solidFill>
+              <a:latin typeface="Calibri"/>
+              <a:ea typeface="Calibri"/>
+              <a:cs typeface="Calibri"/>
+            </a:endParaRPr>
+          </a:p>
+          <a:p>
+            <a:pPr marL="285750">
+              <a:lnSpc>
+                <a:spcPct val="100000"/>
+              </a:lnSpc>
+              <a:spcBef>
+                <a:spcPts val="360"/>
+              </a:spcBef>
+              <a:buClr>
+                <a:srgbClr val="003056"/>
+              </a:buClr>
+              <a:buFont typeface="Arial"/>
+              <a:buChar char="•"/>
+            </a:pPr>
+            <a:endParaRPr lang="en-US" sz="2200" spc="-1" dirty="0">
+              <a:solidFill>
+                <a:srgbClr val="003056"/>
+              </a:solidFill>
+              <a:latin typeface="Calibri"/>
+              <a:ea typeface="Calibri"/>
+              <a:cs typeface="Calibri"/>
+            </a:endParaRPr>
+          </a:p>
+          <a:p>
+            <a:pPr marL="285750">
+              <a:lnSpc>
+                <a:spcPct val="100000"/>
+              </a:lnSpc>
+              <a:spcBef>
+                <a:spcPts val="360"/>
+              </a:spcBef>
+              <a:buClr>
+                <a:srgbClr val="003056"/>
+              </a:buClr>
+              <a:buFont typeface="Arial"/>
+              <a:buChar char="•"/>
+            </a:pPr>
+            <a:endParaRPr lang="en-US" sz="2200" spc="-1" dirty="0">
+              <a:solidFill>
+                <a:srgbClr val="003056"/>
+              </a:solidFill>
+              <a:latin typeface="Calibri"/>
+              <a:ea typeface="Calibri"/>
+              <a:cs typeface="Calibri"/>
+            </a:endParaRPr>
+          </a:p>
+          <a:p>
+            <a:pPr marL="285750">
+              <a:lnSpc>
+                <a:spcPct val="100000"/>
+              </a:lnSpc>
+              <a:spcBef>
+                <a:spcPts val="360"/>
+              </a:spcBef>
+              <a:buClr>
+                <a:srgbClr val="003056"/>
+              </a:buClr>
+              <a:buFont typeface="Arial"/>
+              <a:buChar char="•"/>
+            </a:pPr>
+            <a:endParaRPr lang="en-US" sz="2200" spc="-1" dirty="0">
+              <a:solidFill>
+                <a:srgbClr val="003056"/>
+              </a:solidFill>
+              <a:latin typeface="Calibri"/>
+              <a:ea typeface="Calibri"/>
+              <a:cs typeface="Calibri"/>
+            </a:endParaRPr>
+          </a:p>
+          <a:p>
+            <a:pPr marL="285750">
+              <a:lnSpc>
+                <a:spcPct val="100000"/>
+              </a:lnSpc>
+              <a:spcBef>
+                <a:spcPts val="360"/>
+              </a:spcBef>
+              <a:buClr>
+                <a:srgbClr val="003056"/>
+              </a:buClr>
+              <a:buFont typeface="Arial"/>
+              <a:buChar char="•"/>
+            </a:pPr>
+            <a:r>
+              <a:rPr lang="en-US" sz="2000" spc="-1" dirty="0">
+                <a:solidFill>
+                  <a:srgbClr val="003056"/>
+                </a:solidFill>
+                <a:latin typeface="Calibri"/>
+                <a:ea typeface="Calibri"/>
+                <a:cs typeface="Calibri"/>
+              </a:rPr>
+              <a:t>The top 5 languages cover 4 billion people (50% of the world)</a:t>
+            </a:r>
+            <a:endParaRPr lang="en-US" sz="2200" spc="-1" dirty="0">
+              <a:solidFill>
+                <a:srgbClr val="003056"/>
+              </a:solidFill>
+              <a:latin typeface="Calibri"/>
+              <a:ea typeface="Calibri"/>
+              <a:cs typeface="Calibri"/>
+            </a:endParaRPr>
+          </a:p>
+        </p:txBody>
+      </p:sp>
+      <p:sp>
+        <p:nvSpPr>
+          <p:cNvPr id="5" name="PlaceHolder 4"/>
+          <p:cNvSpPr>
+            <a:spLocks noGrp="1"/>
+          </p:cNvSpPr>
+          <p:nvPr>
+            <p:ph type="sldNum" idx="6"/>
+          </p:nvPr>
+        </p:nvSpPr>
+        <p:spPr/>
+        <p:txBody>
+          <a:bodyPr/>
+          <a:lstStyle/>
+          <a:p>
+            <a:fld id="{AC7497A8-7E1F-45D3-91D1-10848132C468}" type="slidenum">
+              <a:t>3</a:t>
+            </a:fld>
+            <a:endParaRPr/>
+          </a:p>
+        </p:txBody>
+      </p:sp>
+      <p:pic>
+        <p:nvPicPr>
+          <p:cNvPr id="2" name="Picture 1" descr="A screenshot of a computer screen&#10;&#10;Description automatically generated">
+            <a:extLst>
+              <a:ext uri="{FF2B5EF4-FFF2-40B4-BE49-F238E27FC236}">
+                <a16:creationId xmlns:a16="http://schemas.microsoft.com/office/drawing/2014/main" id="{17FAD69A-2516-B2AC-D1CA-E71171629C79}"/>
+              </a:ext>
+            </a:extLst>
+          </p:cNvPr>
+          <p:cNvPicPr>
+            <a:picLocks noChangeAspect="1"/>
+          </p:cNvPicPr>
+          <p:nvPr/>
+        </p:nvPicPr>
+        <p:blipFill>
+          <a:blip r:embed="rId3"/>
+          <a:stretch>
+            <a:fillRect/>
+          </a:stretch>
+        </p:blipFill>
+        <p:spPr>
+          <a:xfrm>
+            <a:off x="512216" y="1909464"/>
+            <a:ext cx="8119567" cy="3380546"/>
+          </a:xfrm>
+          <a:prstGeom prst="rect">
+            <a:avLst/>
+          </a:prstGeom>
+        </p:spPr>
+      </p:pic>
+      <p:sp>
+        <p:nvSpPr>
+          <p:cNvPr id="3" name="TextBox 2">
+            <a:extLst>
+              <a:ext uri="{FF2B5EF4-FFF2-40B4-BE49-F238E27FC236}">
+                <a16:creationId xmlns:a16="http://schemas.microsoft.com/office/drawing/2014/main" id="{092ED94E-BAA0-A65E-DFC2-3F6F03434191}"/>
+              </a:ext>
+            </a:extLst>
+          </p:cNvPr>
+          <p:cNvSpPr txBox="1"/>
+          <p:nvPr/>
+        </p:nvSpPr>
+        <p:spPr>
+          <a:xfrm>
+            <a:off x="7465071" y="5292896"/>
+            <a:ext cx="1166714" cy="307777"/>
+          </a:xfrm>
+          <a:prstGeom prst="rect">
+            <a:avLst/>
+          </a:prstGeom>
+          <a:noFill/>
+        </p:spPr>
+        <p:txBody>
+          <a:bodyPr rot="0" spcFirstLastPara="0" vertOverflow="overflow" horzOverflow="overflow" vert="horz" wrap="square" lIns="91440" tIns="45720" rIns="91440" bIns="45720" numCol="1" spcCol="0" rtlCol="0" fromWordArt="0" anchor="t" anchorCtr="0" forceAA="0" compatLnSpc="1">
+            <a:prstTxWarp prst="textNoShape">
+              <a:avLst/>
+            </a:prstTxWarp>
+            <a:spAutoFit/>
+          </a:bodyPr>
+          <a:lstStyle/>
+          <a:p>
+            <a:r>
+              <a:rPr lang="en-US" sz="1400" dirty="0">
+                <a:latin typeface="Calibri"/>
+                <a:hlinkClick r:id="rId4"/>
+              </a:rPr>
+              <a:t>Image source</a:t>
+            </a:r>
+            <a:endParaRPr lang="en-US" sz="1400" dirty="0">
+              <a:latin typeface="Calibri"/>
+            </a:endParaRPr>
+          </a:p>
+        </p:txBody>
+      </p:sp>
+    </p:spTree>
+    <p:extLst>
+      <p:ext uri="{BB962C8B-B14F-4D97-AF65-F5344CB8AC3E}">
+        <p14:creationId xmlns:p14="http://schemas.microsoft.com/office/powerpoint/2010/main" val="3549647095"/>
+      </p:ext>
+    </p:extLst>
+  </p:cSld>
+  <p:clrMapOvr>
+    <a:masterClrMapping/>
+  </p:clrMapOvr>
+  <p:transition>
+    <p:fade/>
+  </p:transition>
+  <p:timing>
+    <p:tnLst>
+      <p:par>
+        <p:cTn id="1" dur="indefinite" restart="never" nodeType="tmRoot">
+          <p:childTnLst>
+            <p:seq concurrent="1" nextAc="seek">
+              <p:cTn id="2" dur="indefinite" nodeType="mainSeq">
+                <p:childTnLst>
+                  <p:par>
+                    <p:cTn id="3" fill="hold">
+                      <p:stCondLst>
+                        <p:cond delay="indefinite"/>
+                      </p:stCondLst>
+                      <p:childTnLst>
+                        <p:par>
+                          <p:cTn id="4" fill="hold">
+                            <p:stCondLst>
+                              <p:cond delay="0"/>
+                            </p:stCondLst>
+                            <p:childTnLst>
+                              <p:par>
+                                <p:cTn id="5" presetID="1" presetClass="entr" presetSubtype="0" fill="hold" grpId="0" nodeType="clickEffect">
+                                  <p:stCondLst>
+                                    <p:cond delay="0"/>
+                                  </p:stCondLst>
+                                  <p:childTnLst>
+                                    <p:set>
+                                      <p:cBhvr>
+                                        <p:cTn id="6" dur="1" fill="hold">
+                                          <p:stCondLst>
+                                            <p:cond delay="0"/>
+                                          </p:stCondLst>
+                                        </p:cTn>
+                                        <p:tgtEl>
+                                          <p:spTgt spid="95">
+                                            <p:txEl>
+                                              <p:pRg st="0" end="0"/>
+                                            </p:txEl>
+                                          </p:spTgt>
+                                        </p:tgtEl>
+                                        <p:attrNameLst>
+                                          <p:attrName>style.visibility</p:attrName>
+                                        </p:attrNameLst>
+                                      </p:cBhvr>
+                                      <p:to>
+                                        <p:strVal val="visible"/>
+                                      </p:to>
+                                    </p:set>
+                                  </p:childTnLst>
+                                </p:cTn>
+                              </p:par>
+                              <p:par>
+                                <p:cTn id="7" presetID="1" presetClass="entr" presetSubtype="0" fill="hold" grpId="0" nodeType="withEffect">
+                                  <p:stCondLst>
+                                    <p:cond delay="0"/>
+                                  </p:stCondLst>
+                                  <p:childTnLst>
+                                    <p:set>
+                                      <p:cBhvr>
+                                        <p:cTn id="8" dur="1" fill="hold">
+                                          <p:stCondLst>
+                                            <p:cond delay="0"/>
+                                          </p:stCondLst>
+                                        </p:cTn>
+                                        <p:tgtEl>
+                                          <p:spTgt spid="95">
+                                            <p:txEl>
+                                              <p:pRg st="1" end="1"/>
+                                            </p:txEl>
+                                          </p:spTgt>
+                                        </p:tgtEl>
+                                        <p:attrNameLst>
+                                          <p:attrName>style.visibility</p:attrName>
+                                        </p:attrNameLst>
+                                      </p:cBhvr>
+                                      <p:to>
+                                        <p:strVal val="visible"/>
+                                      </p:to>
+                                    </p:set>
+                                  </p:childTnLst>
+                                </p:cTn>
+                              </p:par>
+                              <p:par>
+                                <p:cTn id="9" presetID="1" presetClass="entr" presetSubtype="0" fill="hold" nodeType="withEffect">
+                                  <p:stCondLst>
+                                    <p:cond delay="0"/>
+                                  </p:stCondLst>
+                                  <p:childTnLst>
+                                    <p:set>
+                                      <p:cBhvr>
+                                        <p:cTn id="10" dur="1" fill="hold">
+                                          <p:stCondLst>
+                                            <p:cond delay="0"/>
+                                          </p:stCondLst>
+                                        </p:cTn>
+                                        <p:tgtEl>
+                                          <p:spTgt spid="2"/>
+                                        </p:tgtEl>
+                                        <p:attrNameLst>
+                                          <p:attrName>style.visibility</p:attrName>
+                                        </p:attrNameLst>
+                                      </p:cBhvr>
+                                      <p:to>
+                                        <p:strVal val="visible"/>
+                                      </p:to>
+                                    </p:set>
+                                  </p:childTnLst>
+                                </p:cTn>
+                              </p:par>
+                              <p:par>
+                                <p:cTn id="11" presetID="1" presetClass="entr" presetSubtype="0" fill="hold" grpId="0" nodeType="withEffect">
+                                  <p:stCondLst>
+                                    <p:cond delay="0"/>
+                                  </p:stCondLst>
+                                  <p:childTnLst>
+                                    <p:set>
+                                      <p:cBhvr>
+                                        <p:cTn id="12" dur="1" fill="hold">
+                                          <p:stCondLst>
+                                            <p:cond delay="0"/>
+                                          </p:stCondLst>
+                                        </p:cTn>
+                                        <p:tgtEl>
+                                          <p:spTgt spid="3"/>
+                                        </p:tgtEl>
+                                        <p:attrNameLst>
+                                          <p:attrName>style.visibility</p:attrName>
+                                        </p:attrNameLst>
+                                      </p:cBhvr>
+                                      <p:to>
+                                        <p:strVal val="visible"/>
+                                      </p:to>
+                                    </p:set>
+                                  </p:childTnLst>
+                                </p:cTn>
+                              </p:par>
+                            </p:childTnLst>
+                          </p:cTn>
+                        </p:par>
+                      </p:childTnLst>
+                    </p:cTn>
+                  </p:par>
+                  <p:par>
+                    <p:cTn id="13" fill="hold">
+                      <p:stCondLst>
+                        <p:cond delay="indefinite"/>
+                      </p:stCondLst>
+                      <p:childTnLst>
+                        <p:par>
+                          <p:cTn id="14" fill="hold">
+                            <p:stCondLst>
+                              <p:cond delay="0"/>
+                            </p:stCondLst>
+                            <p:childTnLst>
+                              <p:par>
+                                <p:cTn id="15" presetID="1" presetClass="entr" presetSubtype="0" fill="hold" grpId="0" nodeType="clickEffect">
+                                  <p:stCondLst>
+                                    <p:cond delay="0"/>
+                                  </p:stCondLst>
+                                  <p:childTnLst>
+                                    <p:set>
+                                      <p:cBhvr>
+                                        <p:cTn id="16" dur="1" fill="hold">
+                                          <p:stCondLst>
+                                            <p:cond delay="0"/>
+                                          </p:stCondLst>
+                                        </p:cTn>
+                                        <p:tgtEl>
+                                          <p:spTgt spid="95">
+                                            <p:txEl>
+                                              <p:pRg st="12" end="12"/>
+                                            </p:txEl>
+                                          </p:spTgt>
+                                        </p:tgtEl>
+                                        <p:attrNameLst>
+                                          <p:attrName>style.visibility</p:attrName>
+                                        </p:attrNameLst>
+                                      </p:cBhvr>
+                                      <p:to>
+                                        <p:strVal val="visible"/>
+                                      </p:to>
+                                    </p:set>
+                                  </p:childTnLst>
+                                </p:cTn>
+                              </p:par>
+                            </p:childTnLst>
+                          </p:cTn>
+                        </p:par>
+                      </p:childTnLst>
+                    </p:cTn>
+                  </p:par>
+                </p:childTnLst>
+              </p:cTn>
+              <p:prevCondLst>
+                <p:cond evt="onPrev" delay="0">
+                  <p:tgtEl>
+                    <p:sldTgt/>
+                  </p:tgtEl>
+                </p:cond>
+              </p:prevCondLst>
+              <p:nextCondLst>
+                <p:cond evt="onNext" delay="0">
+                  <p:tgtEl>
+                    <p:sldTgt/>
+                  </p:tgtEl>
+                </p:cond>
+              </p:nextCondLst>
+            </p:seq>
+          </p:childTnLst>
+        </p:cTn>
+      </p:par>
+    </p:tnLst>
+    <p:bldLst>
+      <p:bldP spid="95" grpId="0" build="p"/>
+      <p:bldP spid="3" grpId="0"/>
+    </p:bldLst>
+  </p:timing>
+</p:sld>
+</file>
+
+<file path=ppt/slides/slide30.xml><?xml version="1.0" encoding="utf-8"?>
 <p:sld xmlns:a="http://schemas.openxmlformats.org/drawingml/2006/main" xmlns:r="http://schemas.openxmlformats.org/officeDocument/2006/relationships" xmlns:p="http://schemas.openxmlformats.org/presentationml/2006/main">
   <p:cSld>
     <p:spTree>
@@ -31075,7 +30680,7 @@
           <a:lstStyle/>
           <a:p>
             <a:fld id="{DB375770-8B97-4210-92C0-B7AB3E1F40BE}" type="slidenum">
-              <a:t>31</a:t>
+              <a:t>30</a:t>
             </a:fld>
             <a:endParaRPr/>
           </a:p>
@@ -31745,7 +31350,7 @@
 </p:sld>
 </file>
 
-<file path=ppt/slides/slide32.xml><?xml version="1.0" encoding="utf-8"?>
+<file path=ppt/slides/slide31.xml><?xml version="1.0" encoding="utf-8"?>
 <p:sld xmlns:a="http://schemas.openxmlformats.org/drawingml/2006/main" xmlns:r="http://schemas.openxmlformats.org/officeDocument/2006/relationships" xmlns:p="http://schemas.openxmlformats.org/presentationml/2006/main">
   <p:cSld>
     <p:spTree>
@@ -32331,7 +31936,7 @@
           <a:lstStyle/>
           <a:p>
             <a:fld id="{DB375770-8B97-4210-92C0-B7AB3E1F40BE}" type="slidenum">
-              <a:t>32</a:t>
+              <a:t>31</a:t>
             </a:fld>
             <a:endParaRPr/>
           </a:p>
@@ -32634,7 +32239,7 @@
 </p:sld>
 </file>
 
-<file path=ppt/slides/slide33.xml><?xml version="1.0" encoding="utf-8"?>
+<file path=ppt/slides/slide32.xml><?xml version="1.0" encoding="utf-8"?>
 <p:sld xmlns:a="http://schemas.openxmlformats.org/drawingml/2006/main" xmlns:r="http://schemas.openxmlformats.org/officeDocument/2006/relationships" xmlns:p="http://schemas.openxmlformats.org/presentationml/2006/main">
   <p:cSld>
     <p:spTree>
@@ -33197,7 +32802,7 @@
           <a:lstStyle/>
           <a:p>
             <a:fld id="{DB375770-8B97-4210-92C0-B7AB3E1F40BE}" type="slidenum">
-              <a:t>33</a:t>
+              <a:t>32</a:t>
             </a:fld>
             <a:endParaRPr/>
           </a:p>
@@ -33616,7 +33221,7 @@
 </p:sld>
 </file>
 
-<file path=ppt/slides/slide34.xml><?xml version="1.0" encoding="utf-8"?>
+<file path=ppt/slides/slide33.xml><?xml version="1.0" encoding="utf-8"?>
 <p:sld xmlns:a="http://schemas.openxmlformats.org/drawingml/2006/main" xmlns:r="http://schemas.openxmlformats.org/officeDocument/2006/relationships" xmlns:p="http://schemas.openxmlformats.org/presentationml/2006/main">
   <p:cSld>
     <p:spTree>
@@ -34348,7 +33953,7 @@
           <a:lstStyle/>
           <a:p>
             <a:fld id="{DB375770-8B97-4210-92C0-B7AB3E1F40BE}" type="slidenum">
-              <a:t>34</a:t>
+              <a:t>33</a:t>
             </a:fld>
             <a:endParaRPr/>
           </a:p>
@@ -34909,7 +34514,7 @@
 </p:sld>
 </file>
 
-<file path=ppt/slides/slide35.xml><?xml version="1.0" encoding="utf-8"?>
+<file path=ppt/slides/slide34.xml><?xml version="1.0" encoding="utf-8"?>
 <p:sld xmlns:a="http://schemas.openxmlformats.org/drawingml/2006/main" xmlns:r="http://schemas.openxmlformats.org/officeDocument/2006/relationships" xmlns:p="http://schemas.openxmlformats.org/presentationml/2006/main">
   <p:cSld>
     <p:spTree>
@@ -35369,7 +34974,7 @@
           <a:lstStyle/>
           <a:p>
             <a:fld id="{DB375770-8B97-4210-92C0-B7AB3E1F40BE}" type="slidenum">
-              <a:t>35</a:t>
+              <a:t>34</a:t>
             </a:fld>
             <a:endParaRPr/>
           </a:p>
@@ -35677,7 +35282,7 @@
 </p:sld>
 </file>
 
-<file path=ppt/slides/slide36.xml><?xml version="1.0" encoding="utf-8"?>
+<file path=ppt/slides/slide35.xml><?xml version="1.0" encoding="utf-8"?>
 <p:sld xmlns:a="http://schemas.openxmlformats.org/drawingml/2006/main" xmlns:r="http://schemas.openxmlformats.org/officeDocument/2006/relationships" xmlns:p="http://schemas.openxmlformats.org/presentationml/2006/main">
   <p:cSld>
     <p:spTree>
@@ -36200,7 +35805,7 @@
           <a:lstStyle/>
           <a:p>
             <a:fld id="{DB375770-8B97-4210-92C0-B7AB3E1F40BE}" type="slidenum">
-              <a:t>36</a:t>
+              <a:t>35</a:t>
             </a:fld>
             <a:endParaRPr/>
           </a:p>
@@ -36655,7 +36260,7 @@
 </p:sld>
 </file>
 
-<file path=ppt/slides/slide37.xml><?xml version="1.0" encoding="utf-8"?>
+<file path=ppt/slides/slide36.xml><?xml version="1.0" encoding="utf-8"?>
 <p:sld xmlns:a="http://schemas.openxmlformats.org/drawingml/2006/main" xmlns:r="http://schemas.openxmlformats.org/officeDocument/2006/relationships" xmlns:p="http://schemas.openxmlformats.org/presentationml/2006/main">
   <p:cSld>
     <p:spTree>
@@ -37000,7 +36605,7 @@
           <a:lstStyle/>
           <a:p>
             <a:fld id="{FCB2625B-E8AC-4499-80D0-30520607F22A}" type="slidenum">
-              <a:t>37</a:t>
+              <a:t>36</a:t>
             </a:fld>
             <a:endParaRPr/>
           </a:p>

</xml_diff>